<commit_message>
Demo deck: add 4 code-snippet slides — Shared Preprocessing load_image, DL Dataset+transforms, DL Model Builders, DL Inference+TTA. Skimmable; code in right column with intent bullets on left
</commit_message>
<xml_diff>
--- a/BMET5933_A2_Demo_Deck.pptx
+++ b/BMET5933_A2_Demo_Deck.pptx
@@ -8,10 +8,14 @@
     <p:sldId id="256" r:id="rId2"/>
     <p:sldId id="257" r:id="rId3"/>
     <p:sldId id="258" r:id="rId4"/>
+    <p:sldId id="265" r:id="rId16"/>
     <p:sldId id="259" r:id="rId5"/>
     <p:sldId id="260" r:id="rId6"/>
     <p:sldId id="261" r:id="rId7"/>
+    <p:sldId id="266" r:id="rId17"/>
+    <p:sldId id="267" r:id="rId18"/>
     <p:sldId id="262" r:id="rId8"/>
+    <p:sldId id="268" r:id="rId19"/>
     <p:sldId id="263" r:id="rId9"/>
     <p:sldId id="264" r:id="rId10"/>
   </p:sldIdLst>
@@ -1832,6 +1836,3312 @@
               <a:t>Islam et al. 2022 kidney CT benchmark · 11,929 images · 4 classes</a:t>
             </a:r>
             <a:endParaRPr lang="en-US" sz="1200" dirty="0"/>
+          </a:p>
+        </p:txBody>
+      </p:sp>
+    </p:spTree>
+  </p:cSld>
+  <p:clrMapOvr>
+    <a:masterClrMapping/>
+  </p:clrMapOvr>
+</p:sld>
+</file>
+
+<file path=ppt/slides/slide10.xml><?xml version="1.0" encoding="utf-8"?>
+<p:sld xmlns:a="http://schemas.openxmlformats.org/drawingml/2006/main" xmlns:p="http://schemas.openxmlformats.org/presentationml/2006/main" xmlns:r="http://schemas.openxmlformats.org/officeDocument/2006/relationships">
+  <p:cSld>
+    <p:spTree>
+      <p:nvGrpSpPr>
+        <p:cNvPr id="1" name=""/>
+        <p:cNvGrpSpPr/>
+        <p:nvPr/>
+      </p:nvGrpSpPr>
+      <p:grpSpPr/>
+      <p:sp>
+        <p:nvSpPr>
+          <p:cNvPr id="2" name="Text 0"/>
+          <p:cNvSpPr/>
+          <p:nvPr/>
+        </p:nvSpPr>
+        <p:spPr>
+          <a:xfrm>
+            <a:off x="457200" y="292608"/>
+            <a:ext cx="7772400" cy="502920"/>
+          </a:xfrm>
+          <a:prstGeom prst="rect">
+            <a:avLst/>
+          </a:prstGeom>
+          <a:noFill/>
+          <a:ln/>
+        </p:spPr>
+        <p:txBody>
+          <a:bodyPr wrap="square" lIns="0" tIns="0" rIns="0" bIns="0" rtlCol="0" anchor="t"/>
+          <a:lstStyle/>
+          <a:p>
+            <a:pPr indent="0" marL="0">
+              <a:buNone/>
+            </a:pPr>
+            <a:r>
+              <a:rPr lang="en-US" sz="2800" b="1" dirty="0">
+                <a:solidFill>
+                  <a:srgbClr val="2D3142"/>
+                </a:solidFill>
+                <a:latin typeface="Calibri" pitchFamily="34" charset="0"/>
+                <a:ea typeface="Calibri" pitchFamily="34" charset="-122"/>
+                <a:cs typeface="Calibri" pitchFamily="34" charset="-120"/>
+              </a:rPr>
+              <a:t>Shared Preprocessing  ·  load_image()</a:t>
+            </a:r>
+            <a:endParaRPr lang="en-US" sz="2800" dirty="0"/>
+          </a:p>
+        </p:txBody>
+      </p:sp>
+      <p:sp>
+        <p:nvSpPr>
+          <p:cNvPr id="3" name="Text 1"/>
+          <p:cNvSpPr/>
+          <p:nvPr/>
+        </p:nvSpPr>
+        <p:spPr>
+          <a:xfrm>
+            <a:off x="5943600" y="292608"/>
+            <a:ext cx="2834640" cy="292608"/>
+          </a:xfrm>
+          <a:prstGeom prst="rect">
+            <a:avLst/>
+          </a:prstGeom>
+          <a:noFill/>
+          <a:ln/>
+        </p:spPr>
+        <p:txBody>
+          <a:bodyPr wrap="square" lIns="0" tIns="0" rIns="0" bIns="0" rtlCol="0" anchor="t"/>
+          <a:lstStyle/>
+          <a:p>
+            <a:pPr algn="r" indent="0" marL="0">
+              <a:buNone/>
+            </a:pPr>
+            <a:r>
+              <a:rPr lang="en-US" sz="900" b="1" spc="400" kern="0" dirty="0">
+                <a:solidFill>
+                  <a:srgbClr val="75948A"/>
+                </a:solidFill>
+                <a:latin typeface="Calibri" pitchFamily="34" charset="0"/>
+                <a:ea typeface="Calibri" pitchFamily="34" charset="-122"/>
+                <a:cs typeface="Calibri" pitchFamily="34" charset="-120"/>
+              </a:rPr>
+              <a:t>METHODS · SHARED INFRASTRUCTURE</a:t>
+            </a:r>
+            <a:endParaRPr lang="en-US" sz="900" dirty="0"/>
+          </a:p>
+        </p:txBody>
+      </p:sp>
+      <p:sp>
+        <p:nvSpPr>
+          <p:cNvPr id="4" name="Text 2"/>
+          <p:cNvSpPr/>
+          <p:nvPr/>
+        </p:nvSpPr>
+        <p:spPr>
+          <a:xfrm>
+            <a:off x="457200" y="1143000"/>
+            <a:ext cx="3931920" cy="292608"/>
+          </a:xfrm>
+          <a:prstGeom prst="rect">
+            <a:avLst/>
+          </a:prstGeom>
+          <a:noFill/>
+          <a:ln/>
+        </p:spPr>
+        <p:txBody>
+          <a:bodyPr wrap="square" lIns="0" tIns="0" rIns="0" bIns="0" rtlCol="0" anchor="t"/>
+          <a:lstStyle/>
+          <a:p>
+            <a:pPr indent="0" marL="0">
+              <a:buNone/>
+            </a:pPr>
+            <a:r>
+              <a:rPr lang="en-US" sz="1500" b="1" dirty="0">
+                <a:solidFill>
+                  <a:srgbClr val="B85042"/>
+                </a:solidFill>
+                <a:latin typeface="Calibri" pitchFamily="34" charset="0"/>
+                <a:ea typeface="Calibri" pitchFamily="34" charset="-122"/>
+                <a:cs typeface="Calibri" pitchFamily="34" charset="-120"/>
+              </a:rPr>
+              <a:t>What every model sees</a:t>
+            </a:r>
+            <a:endParaRPr lang="en-US" sz="1500" dirty="0"/>
+          </a:p>
+        </p:txBody>
+      </p:sp>
+      <p:sp>
+        <p:nvSpPr>
+          <p:cNvPr id="5" name="Shape 3"/>
+          <p:cNvSpPr/>
+          <p:nvPr/>
+        </p:nvSpPr>
+        <p:spPr>
+          <a:xfrm>
+            <a:off x="457200" y="1508760"/>
+            <a:ext cx="3931920" cy="777240"/>
+          </a:xfrm>
+          <a:prstGeom prst="rect">
+            <a:avLst/>
+          </a:prstGeom>
+          <a:solidFill>
+            <a:srgbClr val="EDE6D6"/>
+          </a:solidFill>
+          <a:ln w="12700">
+            <a:solidFill>
+              <a:srgbClr val="EDE6D6"/>
+            </a:solidFill>
+            <a:prstDash val="solid"/>
+          </a:ln>
+        </p:spPr>
+        <p:txBody>
+          <a:bodyPr/>
+          <a:p>
+            <a:r>
+              <a:t/>
+            </a:r>
+          </a:p>
+        </p:txBody>
+      </p:sp>
+      <p:sp>
+        <p:nvSpPr>
+          <p:cNvPr id="6" name="Shape 4"/>
+          <p:cNvSpPr/>
+          <p:nvPr/>
+        </p:nvSpPr>
+        <p:spPr>
+          <a:xfrm>
+            <a:off x="457200" y="1508760"/>
+            <a:ext cx="91440" cy="777240"/>
+          </a:xfrm>
+          <a:prstGeom prst="rect">
+            <a:avLst/>
+          </a:prstGeom>
+          <a:solidFill>
+            <a:srgbClr val="75948A"/>
+          </a:solidFill>
+          <a:ln w="12700">
+            <a:solidFill>
+              <a:srgbClr val="75948A"/>
+            </a:solidFill>
+            <a:prstDash val="solid"/>
+          </a:ln>
+        </p:spPr>
+        <p:txBody>
+          <a:bodyPr/>
+          <a:p>
+            <a:r>
+              <a:t/>
+            </a:r>
+          </a:p>
+        </p:txBody>
+      </p:sp>
+      <p:sp>
+        <p:nvSpPr>
+          <p:cNvPr id="7" name="Text 5"/>
+          <p:cNvSpPr/>
+          <p:nvPr/>
+        </p:nvSpPr>
+        <p:spPr>
+          <a:xfrm>
+            <a:off x="640080" y="1554480"/>
+            <a:ext cx="3657600" cy="228600"/>
+          </a:xfrm>
+          <a:prstGeom prst="rect">
+            <a:avLst/>
+          </a:prstGeom>
+          <a:noFill/>
+          <a:ln/>
+        </p:spPr>
+        <p:txBody>
+          <a:bodyPr wrap="square" lIns="0" tIns="0" rIns="0" bIns="0" rtlCol="0" anchor="t"/>
+          <a:lstStyle/>
+          <a:p>
+            <a:pPr indent="0" marL="0">
+              <a:buNone/>
+            </a:pPr>
+            <a:r>
+              <a:rPr lang="en-US" sz="1000" b="1" spc="300" kern="0" dirty="0">
+                <a:solidFill>
+                  <a:srgbClr val="75948A"/>
+                </a:solidFill>
+                <a:latin typeface="Calibri" pitchFamily="34" charset="0"/>
+                <a:ea typeface="Calibri" pitchFamily="34" charset="-122"/>
+                <a:cs typeface="Calibri" pitchFamily="34" charset="-120"/>
+              </a:rPr>
+              <a:t/>
+            </a:r>
+            <a:endParaRPr lang="en-US" sz="1000" dirty="0"/>
+          </a:p>
+        </p:txBody>
+      </p:sp>
+      <p:sp>
+        <p:nvSpPr>
+          <p:cNvPr id="8" name="Text 6"/>
+          <p:cNvSpPr/>
+          <p:nvPr/>
+        </p:nvSpPr>
+        <p:spPr>
+          <a:xfrm>
+            <a:off x="640080" y="1801368"/>
+            <a:ext cx="3657600" cy="411480"/>
+          </a:xfrm>
+          <a:prstGeom prst="rect">
+            <a:avLst/>
+          </a:prstGeom>
+          <a:noFill/>
+          <a:ln/>
+        </p:spPr>
+        <p:txBody>
+          <a:bodyPr wrap="square" lIns="0" tIns="0" rIns="0" bIns="0" rtlCol="0" anchor="t"/>
+          <a:lstStyle/>
+          <a:p>
+            <a:pPr indent="0" marL="0">
+              <a:buNone/>
+            </a:pPr>
+            <a:r>
+              <a:rPr lang="en-US" sz="1250" dirty="0">
+                <a:solidFill>
+                  <a:srgbClr val="2D3142"/>
+                </a:solidFill>
+                <a:latin typeface="Calibri" pitchFamily="34" charset="0"/>
+                <a:ea typeface="Calibri" pitchFamily="34" charset="-122"/>
+                <a:cs typeface="Calibri" pitchFamily="34" charset="-120"/>
+              </a:rPr>
+              <a:t/>
+            </a:r>
+            <a:endParaRPr lang="en-US" sz="1250" dirty="0"/>
+          </a:p>
+        </p:txBody>
+      </p:sp>
+      <p:sp>
+        <p:nvSpPr>
+          <p:cNvPr id="9" name="Shape 7"/>
+          <p:cNvSpPr/>
+          <p:nvPr/>
+        </p:nvSpPr>
+        <p:spPr>
+          <a:xfrm>
+            <a:off x="457200" y="2377440"/>
+            <a:ext cx="3931920" cy="1463040"/>
+          </a:xfrm>
+          <a:prstGeom prst="rect">
+            <a:avLst/>
+          </a:prstGeom>
+          <a:solidFill>
+            <a:srgbClr val="EDE6D6"/>
+          </a:solidFill>
+          <a:ln w="12700">
+            <a:solidFill>
+              <a:srgbClr val="EDE6D6"/>
+            </a:solidFill>
+            <a:prstDash val="solid"/>
+          </a:ln>
+        </p:spPr>
+        <p:txBody>
+          <a:bodyPr/>
+          <a:p>
+            <a:r>
+              <a:rPr>
+                <a:solidFill/>
+              </a:rPr>
+              <a:t>PIL grayscale convert ('L' mode) — CT is 1-channel intensity</a:t>
+            </a:r>
+          </a:p>
+          <a:p>
+            <a:r>
+              <a:rPr b="0"/>
+              <a:t>Square center-crop to min(w, h) — preserves kidney anatomy</a:t>
+            </a:r>
+          </a:p>
+          <a:p>
+            <a:r>
+              <a:rPr b="0"/>
+              <a:t>Resize to 256 × 256 with bilinear interpolation</a:t>
+            </a:r>
+          </a:p>
+          <a:p>
+            <a:r>
+              <a:rPr b="0"/>
+              <a:t>Return uint8 numpy array — pipeline-specific casts come later</a:t>
+            </a:r>
+          </a:p>
+          <a:p>
+            <a:r>
+              <a:rPr b="0"/>
+              <a:t/>
+            </a:r>
+          </a:p>
+          <a:p>
+            <a:r>
+              <a:rPr b="0"/>
+              <a:t>Same function feeds classical (CLAHE → 138-dim features)</a:t>
+            </a:r>
+          </a:p>
+          <a:p>
+            <a:r>
+              <a:rPr b="0"/>
+              <a:t>and DL (3-channel replication → ImageNet normalise)</a:t>
+            </a:r>
+          </a:p>
+        </p:txBody>
+      </p:sp>
+      <p:sp>
+        <p:nvSpPr>
+          <p:cNvPr id="10" name="Shape 8"/>
+          <p:cNvSpPr/>
+          <p:nvPr/>
+        </p:nvSpPr>
+        <p:spPr>
+          <a:xfrm>
+            <a:off x="457200" y="2377440"/>
+            <a:ext cx="91440" cy="1463040"/>
+          </a:xfrm>
+          <a:prstGeom prst="rect">
+            <a:avLst/>
+          </a:prstGeom>
+          <a:solidFill>
+            <a:srgbClr val="B85042"/>
+          </a:solidFill>
+          <a:ln w="12700">
+            <a:solidFill>
+              <a:srgbClr val="B85042"/>
+            </a:solidFill>
+            <a:prstDash val="solid"/>
+          </a:ln>
+        </p:spPr>
+        <p:txBody>
+          <a:bodyPr/>
+          <a:p>
+            <a:r>
+              <a:t/>
+            </a:r>
+          </a:p>
+        </p:txBody>
+      </p:sp>
+      <p:sp>
+        <p:nvSpPr>
+          <p:cNvPr id="11" name="Text 9"/>
+          <p:cNvSpPr/>
+          <p:nvPr/>
+        </p:nvSpPr>
+        <p:spPr>
+          <a:xfrm>
+            <a:off x="640080" y="2423160"/>
+            <a:ext cx="3657600" cy="228600"/>
+          </a:xfrm>
+          <a:prstGeom prst="rect">
+            <a:avLst/>
+          </a:prstGeom>
+          <a:noFill/>
+          <a:ln/>
+        </p:spPr>
+        <p:txBody>
+          <a:bodyPr wrap="square" lIns="0" tIns="0" rIns="0" bIns="0" rtlCol="0" anchor="t"/>
+          <a:lstStyle/>
+          <a:p>
+            <a:pPr indent="0" marL="0">
+              <a:buNone/>
+            </a:pPr>
+            <a:r>
+              <a:rPr lang="en-US" sz="1000" b="1" spc="300" kern="0" dirty="0">
+                <a:solidFill>
+                  <a:srgbClr val="B85042"/>
+                </a:solidFill>
+                <a:latin typeface="Calibri" pitchFamily="34" charset="0"/>
+                <a:ea typeface="Calibri" pitchFamily="34" charset="-122"/>
+                <a:cs typeface="Calibri" pitchFamily="34" charset="-120"/>
+              </a:rPr>
+              <a:t/>
+            </a:r>
+            <a:endParaRPr lang="en-US" sz="1000" dirty="0"/>
+          </a:p>
+        </p:txBody>
+      </p:sp>
+      <p:sp>
+        <p:nvSpPr>
+          <p:cNvPr id="12" name="Text 10"/>
+          <p:cNvSpPr/>
+          <p:nvPr/>
+        </p:nvSpPr>
+        <p:spPr>
+          <a:xfrm>
+            <a:off x="640080" y="2651760"/>
+            <a:ext cx="3657600" cy="1280160"/>
+          </a:xfrm>
+          <a:prstGeom prst="rect">
+            <a:avLst/>
+          </a:prstGeom>
+          <a:noFill/>
+          <a:ln/>
+        </p:spPr>
+        <p:txBody>
+          <a:bodyPr wrap="square" lIns="0" tIns="0" rIns="0" bIns="0" rtlCol="0" anchor="t"/>
+          <a:lstStyle/>
+          <a:p>
+            <a:pPr indent="0" marL="0">
+              <a:spcAft>
+                <a:spcPts val="200"/>
+              </a:spcAft>
+              <a:buNone/>
+            </a:pPr>
+            <a:r>
+              <a:rPr lang="en-US" sz="1150" dirty="0">
+                <a:solidFill>
+                  <a:srgbClr val="2D3142"/>
+                </a:solidFill>
+                <a:latin typeface="Calibri" pitchFamily="34" charset="0"/>
+                <a:ea typeface="Calibri" pitchFamily="34" charset="-122"/>
+                <a:cs typeface="Calibri" pitchFamily="34" charset="-120"/>
+              </a:rPr>
+              <a:t/>
+            </a:r>
+            <a:endParaRPr lang="en-US" sz="1150" dirty="0"/>
+          </a:p>
+        </p:txBody>
+      </p:sp>
+      <p:sp>
+        <p:nvSpPr>
+          <p:cNvPr id="13" name="Text 11"/>
+          <p:cNvSpPr/>
+          <p:nvPr/>
+        </p:nvSpPr>
+        <p:spPr>
+          <a:xfrm>
+            <a:off x="457200" y="3977640"/>
+            <a:ext cx="3931920" cy="548640"/>
+          </a:xfrm>
+          <a:prstGeom prst="rect">
+            <a:avLst/>
+          </a:prstGeom>
+          <a:noFill/>
+          <a:ln/>
+        </p:spPr>
+        <p:txBody>
+          <a:bodyPr wrap="square" lIns="0" tIns="0" rIns="0" bIns="0" rtlCol="0" anchor="t"/>
+          <a:lstStyle/>
+          <a:p>
+            <a:pPr indent="0" marL="0">
+              <a:spcAft>
+                <a:spcPts val="200"/>
+              </a:spcAft>
+              <a:buNone/>
+            </a:pPr>
+            <a:r>
+              <a:rPr lang="en-US" sz="1150" b="1" dirty="0">
+                <a:solidFill>
+                  <a:srgbClr val="B85042"/>
+                </a:solidFill>
+                <a:latin typeface="Calibri" pitchFamily="34" charset="0"/>
+                <a:ea typeface="Calibri" pitchFamily="34" charset="-122"/>
+                <a:cs typeface="Calibri" pitchFamily="34" charset="-120"/>
+              </a:rPr>
+              <a:t/>
+            </a:r>
+            <a:pPr indent="0" marL="0">
+              <a:spcAft>
+                <a:spcPts val="200"/>
+              </a:spcAft>
+              <a:buNone/>
+            </a:pPr>
+            <a:endParaRPr lang="en-US" sz="1150" dirty="0"/>
+          </a:p>
+        </p:txBody>
+      </p:sp>
+      <p:sp>
+        <p:nvSpPr>
+          <p:cNvPr id="14" name="Text 12"/>
+          <p:cNvSpPr/>
+          <p:nvPr/>
+        </p:nvSpPr>
+        <p:spPr>
+          <a:xfrm>
+            <a:off x="4572000" y="1143000"/>
+            <a:ext cx="4389120" cy="292608"/>
+          </a:xfrm>
+          <a:prstGeom prst="rect">
+            <a:avLst/>
+          </a:prstGeom>
+          <a:noFill/>
+          <a:ln/>
+        </p:spPr>
+        <p:txBody>
+          <a:bodyPr wrap="square" lIns="0" tIns="0" rIns="0" bIns="0" rtlCol="0" anchor="t"/>
+          <a:lstStyle/>
+          <a:p>
+            <a:pPr indent="0" marL="0">
+              <a:buNone/>
+            </a:pPr>
+            <a:r>
+              <a:rPr lang="en-US" sz="1500" b="1" dirty="0">
+                <a:solidFill>
+                  <a:srgbClr val="B85042"/>
+                </a:solidFill>
+                <a:latin typeface="Calibri" pitchFamily="34" charset="0"/>
+                <a:ea typeface="Calibri" pitchFamily="34" charset="-122"/>
+                <a:cs typeface="Calibri" pitchFamily="34" charset="-120"/>
+              </a:rPr>
+              <a:t>Code  ·  shared/preprocessing.py</a:t>
+            </a:r>
+            <a:endParaRPr lang="en-US" sz="1500" dirty="0"/>
+          </a:p>
+        </p:txBody>
+      </p:sp>
+      <p:sp>
+        <p:nvSpPr>
+          <p:cNvPr id="15" name="Shape 13"/>
+          <p:cNvSpPr/>
+          <p:nvPr/>
+        </p:nvSpPr>
+        <p:spPr>
+          <a:xfrm>
+            <a:off x="4572000" y="1508760"/>
+            <a:ext cx="4389120" cy="3383280"/>
+          </a:xfrm>
+          <a:prstGeom prst="rect">
+            <a:avLst/>
+          </a:prstGeom>
+          <a:solidFill>
+            <a:srgbClr val="1E293B"/>
+          </a:solidFill>
+          <a:ln w="12700">
+            <a:solidFill>
+              <a:srgbClr val="1E293B"/>
+            </a:solidFill>
+            <a:prstDash val="solid"/>
+          </a:ln>
+        </p:spPr>
+        <p:txBody>
+          <a:bodyPr/>
+          <a:p>
+            <a:r>
+              <a:t/>
+            </a:r>
+          </a:p>
+        </p:txBody>
+      </p:sp>
+      <p:sp>
+        <p:nvSpPr>
+          <p:cNvPr id="16" name="Text 14"/>
+          <p:cNvSpPr/>
+          <p:nvPr/>
+        </p:nvSpPr>
+        <p:spPr>
+          <a:xfrm>
+            <a:off x="4709160" y="1600200"/>
+            <a:ext cx="4114800" cy="3200400"/>
+          </a:xfrm>
+          <a:prstGeom prst="rect">
+            <a:avLst/>
+          </a:prstGeom>
+          <a:noFill/>
+          <a:ln/>
+        </p:spPr>
+        <p:txBody>
+          <a:bodyPr wrap="square" lIns="0" tIns="0" rIns="0" bIns="0" rtlCol="0" anchor="t"/>
+          <a:lstStyle/>
+          <a:p>
+            <a:pPr indent="0" marL="0">
+              <a:buNone/>
+            </a:pPr>
+            <a:r>
+              <a:rPr lang="en-US" sz="1050" dirty="0">
+                <a:solidFill>
+                  <a:srgbClr val="F0B27A"/>
+                </a:solidFill>
+                <a:latin typeface="Courier New" pitchFamily="34" charset="0"/>
+                <a:ea typeface="Courier New" pitchFamily="34" charset="-122"/>
+                <a:cs typeface="Courier New" pitchFamily="34" charset="-120"/>
+              </a:rPr>
+              <a:t>from PIL import Image</a:t>
+            </a:r>
+            <a:pPr indent="0" marL="0">
+              <a:buNone/>
+            </a:pPr>
+            <a:endParaRPr lang="en-US" sz="1050" dirty="0"/>
+          </a:p>
+          <a:p>
+            <a:r>
+              <a:rPr sz="1050" b="0">
+                <a:solidFill>
+                  <a:srgbClr val="F0B27A"/>
+                </a:solidFill>
+                <a:latin typeface="Courier New"/>
+              </a:rPr>
+              <a:t>import numpy as np</a:t>
+            </a:r>
+          </a:p>
+          <a:p>
+            <a:r>
+              <a:rPr sz="1050" b="0">
+                <a:solidFill>
+                  <a:srgbClr val="F0B27A"/>
+                </a:solidFill>
+                <a:latin typeface="Courier New"/>
+              </a:rPr>
+              <a:t>from shared.config import IMAGE_SIZE</a:t>
+            </a:r>
+          </a:p>
+          <a:p>
+            <a:r>
+              <a:rPr sz="1050" b="0">
+                <a:solidFill>
+                  <a:srgbClr val="F0B27A"/>
+                </a:solidFill>
+                <a:latin typeface="Courier New"/>
+              </a:rPr>
+              <a:t/>
+            </a:r>
+          </a:p>
+          <a:p>
+            <a:r>
+              <a:rPr sz="1050" b="0">
+                <a:solidFill>
+                  <a:srgbClr val="F0B27A"/>
+                </a:solidFill>
+                <a:latin typeface="Courier New"/>
+              </a:rPr>
+              <a:t>def load_image(path):</a:t>
+            </a:r>
+          </a:p>
+          <a:p>
+            <a:r>
+              <a:rPr sz="1050" b="0">
+                <a:solidFill>
+                  <a:srgbClr val="F0B27A"/>
+                </a:solidFill>
+                <a:latin typeface="Courier New"/>
+              </a:rPr>
+              <a:t>    img = Image.open(path).convert('L')</a:t>
+            </a:r>
+          </a:p>
+          <a:p>
+            <a:r>
+              <a:rPr sz="1050" b="0">
+                <a:solidFill>
+                  <a:srgbClr val="F0B27A"/>
+                </a:solidFill>
+                <a:latin typeface="Courier New"/>
+              </a:rPr>
+              <a:t>    w, h = img.size</a:t>
+            </a:r>
+          </a:p>
+          <a:p>
+            <a:r>
+              <a:rPr sz="1050" b="0">
+                <a:solidFill>
+                  <a:srgbClr val="F0B27A"/>
+                </a:solidFill>
+                <a:latin typeface="Courier New"/>
+              </a:rPr>
+              <a:t>    m = min(w, h)</a:t>
+            </a:r>
+          </a:p>
+          <a:p>
+            <a:r>
+              <a:rPr sz="1050" b="0">
+                <a:solidFill>
+                  <a:srgbClr val="F0B27A"/>
+                </a:solidFill>
+                <a:latin typeface="Courier New"/>
+              </a:rPr>
+              <a:t>    left = (w - m) // 2</a:t>
+            </a:r>
+          </a:p>
+          <a:p>
+            <a:r>
+              <a:rPr sz="1050" b="0">
+                <a:solidFill>
+                  <a:srgbClr val="F0B27A"/>
+                </a:solidFill>
+                <a:latin typeface="Courier New"/>
+              </a:rPr>
+              <a:t>    top  = (h - m) // 2</a:t>
+            </a:r>
+          </a:p>
+          <a:p>
+            <a:r>
+              <a:rPr sz="1050" b="0">
+                <a:solidFill>
+                  <a:srgbClr val="F0B27A"/>
+                </a:solidFill>
+                <a:latin typeface="Courier New"/>
+              </a:rPr>
+              <a:t>    img = img.crop(</a:t>
+            </a:r>
+          </a:p>
+          <a:p>
+            <a:r>
+              <a:rPr sz="1050" b="0">
+                <a:solidFill>
+                  <a:srgbClr val="F0B27A"/>
+                </a:solidFill>
+                <a:latin typeface="Courier New"/>
+              </a:rPr>
+              <a:t>        (left, top, left+m, top+m))</a:t>
+            </a:r>
+          </a:p>
+          <a:p>
+            <a:r>
+              <a:rPr sz="1050" b="0">
+                <a:solidFill>
+                  <a:srgbClr val="F0B27A"/>
+                </a:solidFill>
+                <a:latin typeface="Courier New"/>
+              </a:rPr>
+              <a:t>    img = img.resize(</a:t>
+            </a:r>
+          </a:p>
+          <a:p>
+            <a:r>
+              <a:rPr sz="1050" b="0">
+                <a:solidFill>
+                  <a:srgbClr val="F0B27A"/>
+                </a:solidFill>
+                <a:latin typeface="Courier New"/>
+              </a:rPr>
+              <a:t>        IMAGE_SIZE, Image.BILINEAR)</a:t>
+            </a:r>
+          </a:p>
+          <a:p>
+            <a:r>
+              <a:rPr sz="1050" b="0">
+                <a:solidFill>
+                  <a:srgbClr val="F0B27A"/>
+                </a:solidFill>
+                <a:latin typeface="Courier New"/>
+              </a:rPr>
+              <a:t>    return np.asarray(img, dtype=np.uint8)</a:t>
+            </a:r>
+          </a:p>
+        </p:txBody>
+      </p:sp>
+    </p:spTree>
+  </p:cSld>
+  <p:clrMapOvr>
+    <a:masterClrMapping/>
+  </p:clrMapOvr>
+</p:sld>
+</file>
+
+<file path=ppt/slides/slide11.xml><?xml version="1.0" encoding="utf-8"?>
+<p:sld xmlns:a="http://schemas.openxmlformats.org/drawingml/2006/main" xmlns:p="http://schemas.openxmlformats.org/presentationml/2006/main" xmlns:r="http://schemas.openxmlformats.org/officeDocument/2006/relationships">
+  <p:cSld>
+    <p:spTree>
+      <p:nvGrpSpPr>
+        <p:cNvPr id="1" name=""/>
+        <p:cNvGrpSpPr/>
+        <p:nvPr/>
+      </p:nvGrpSpPr>
+      <p:grpSpPr/>
+      <p:sp>
+        <p:nvSpPr>
+          <p:cNvPr id="2" name="Text 0"/>
+          <p:cNvSpPr/>
+          <p:nvPr/>
+        </p:nvSpPr>
+        <p:spPr>
+          <a:xfrm>
+            <a:off x="457200" y="292608"/>
+            <a:ext cx="7772400" cy="502920"/>
+          </a:xfrm>
+          <a:prstGeom prst="rect">
+            <a:avLst/>
+          </a:prstGeom>
+          <a:noFill/>
+          <a:ln/>
+        </p:spPr>
+        <p:txBody>
+          <a:bodyPr wrap="square" lIns="0" tIns="0" rIns="0" bIns="0" rtlCol="0" anchor="t"/>
+          <a:lstStyle/>
+          <a:p>
+            <a:pPr indent="0" marL="0">
+              <a:buNone/>
+            </a:pPr>
+            <a:r>
+              <a:rPr lang="en-US" sz="2800" b="1" dirty="0">
+                <a:solidFill>
+                  <a:srgbClr val="2D3142"/>
+                </a:solidFill>
+                <a:latin typeface="Calibri" pitchFamily="34" charset="0"/>
+                <a:ea typeface="Calibri" pitchFamily="34" charset="-122"/>
+                <a:cs typeface="Calibri" pitchFamily="34" charset="-120"/>
+              </a:rPr>
+              <a:t>DL Dataset  ·  KidneyCTDataset + transforms</a:t>
+            </a:r>
+            <a:endParaRPr lang="en-US" sz="2800" dirty="0"/>
+          </a:p>
+        </p:txBody>
+      </p:sp>
+      <p:sp>
+        <p:nvSpPr>
+          <p:cNvPr id="3" name="Text 1"/>
+          <p:cNvSpPr/>
+          <p:nvPr/>
+        </p:nvSpPr>
+        <p:spPr>
+          <a:xfrm>
+            <a:off x="5943600" y="292608"/>
+            <a:ext cx="2834640" cy="292608"/>
+          </a:xfrm>
+          <a:prstGeom prst="rect">
+            <a:avLst/>
+          </a:prstGeom>
+          <a:noFill/>
+          <a:ln/>
+        </p:spPr>
+        <p:txBody>
+          <a:bodyPr wrap="square" lIns="0" tIns="0" rIns="0" bIns="0" rtlCol="0" anchor="t"/>
+          <a:lstStyle/>
+          <a:p>
+            <a:pPr algn="r" indent="0" marL="0">
+              <a:buNone/>
+            </a:pPr>
+            <a:r>
+              <a:rPr lang="en-US" sz="900" b="1" spc="400" kern="0" dirty="0">
+                <a:solidFill>
+                  <a:srgbClr val="75948A"/>
+                </a:solidFill>
+                <a:latin typeface="Calibri" pitchFamily="34" charset="0"/>
+                <a:ea typeface="Calibri" pitchFamily="34" charset="-122"/>
+                <a:cs typeface="Calibri" pitchFamily="34" charset="-120"/>
+              </a:rPr>
+              <a:t>METHODS · DEEP LEARNING · JAMES</a:t>
+            </a:r>
+            <a:endParaRPr lang="en-US" sz="900" dirty="0"/>
+          </a:p>
+        </p:txBody>
+      </p:sp>
+      <p:sp>
+        <p:nvSpPr>
+          <p:cNvPr id="4" name="Text 2"/>
+          <p:cNvSpPr/>
+          <p:nvPr/>
+        </p:nvSpPr>
+        <p:spPr>
+          <a:xfrm>
+            <a:off x="457200" y="1143000"/>
+            <a:ext cx="3931920" cy="292608"/>
+          </a:xfrm>
+          <a:prstGeom prst="rect">
+            <a:avLst/>
+          </a:prstGeom>
+          <a:noFill/>
+          <a:ln/>
+        </p:spPr>
+        <p:txBody>
+          <a:bodyPr wrap="square" lIns="0" tIns="0" rIns="0" bIns="0" rtlCol="0" anchor="t"/>
+          <a:lstStyle/>
+          <a:p>
+            <a:pPr indent="0" marL="0">
+              <a:buNone/>
+            </a:pPr>
+            <a:r>
+              <a:rPr lang="en-US" sz="1500" b="1" dirty="0">
+                <a:solidFill>
+                  <a:srgbClr val="B85042"/>
+                </a:solidFill>
+                <a:latin typeface="Calibri" pitchFamily="34" charset="0"/>
+                <a:ea typeface="Calibri" pitchFamily="34" charset="-122"/>
+                <a:cs typeface="Calibri" pitchFamily="34" charset="-120"/>
+              </a:rPr>
+              <a:t>From grayscale uint8 → CNN tensor</a:t>
+            </a:r>
+            <a:endParaRPr lang="en-US" sz="1500" dirty="0"/>
+          </a:p>
+        </p:txBody>
+      </p:sp>
+      <p:sp>
+        <p:nvSpPr>
+          <p:cNvPr id="5" name="Shape 3"/>
+          <p:cNvSpPr/>
+          <p:nvPr/>
+        </p:nvSpPr>
+        <p:spPr>
+          <a:xfrm>
+            <a:off x="457200" y="1508760"/>
+            <a:ext cx="3931920" cy="777240"/>
+          </a:xfrm>
+          <a:prstGeom prst="rect">
+            <a:avLst/>
+          </a:prstGeom>
+          <a:solidFill>
+            <a:srgbClr val="EDE6D6"/>
+          </a:solidFill>
+          <a:ln w="12700">
+            <a:solidFill>
+              <a:srgbClr val="EDE6D6"/>
+            </a:solidFill>
+            <a:prstDash val="solid"/>
+          </a:ln>
+        </p:spPr>
+        <p:txBody>
+          <a:bodyPr/>
+          <a:p>
+            <a:r>
+              <a:t/>
+            </a:r>
+          </a:p>
+        </p:txBody>
+      </p:sp>
+      <p:sp>
+        <p:nvSpPr>
+          <p:cNvPr id="6" name="Shape 4"/>
+          <p:cNvSpPr/>
+          <p:nvPr/>
+        </p:nvSpPr>
+        <p:spPr>
+          <a:xfrm>
+            <a:off x="457200" y="1508760"/>
+            <a:ext cx="91440" cy="777240"/>
+          </a:xfrm>
+          <a:prstGeom prst="rect">
+            <a:avLst/>
+          </a:prstGeom>
+          <a:solidFill>
+            <a:srgbClr val="75948A"/>
+          </a:solidFill>
+          <a:ln w="12700">
+            <a:solidFill>
+              <a:srgbClr val="75948A"/>
+            </a:solidFill>
+            <a:prstDash val="solid"/>
+          </a:ln>
+        </p:spPr>
+        <p:txBody>
+          <a:bodyPr/>
+          <a:p>
+            <a:r>
+              <a:t/>
+            </a:r>
+          </a:p>
+        </p:txBody>
+      </p:sp>
+      <p:sp>
+        <p:nvSpPr>
+          <p:cNvPr id="7" name="Text 5"/>
+          <p:cNvSpPr/>
+          <p:nvPr/>
+        </p:nvSpPr>
+        <p:spPr>
+          <a:xfrm>
+            <a:off x="640080" y="1554480"/>
+            <a:ext cx="3657600" cy="228600"/>
+          </a:xfrm>
+          <a:prstGeom prst="rect">
+            <a:avLst/>
+          </a:prstGeom>
+          <a:noFill/>
+          <a:ln/>
+        </p:spPr>
+        <p:txBody>
+          <a:bodyPr wrap="square" lIns="0" tIns="0" rIns="0" bIns="0" rtlCol="0" anchor="t"/>
+          <a:lstStyle/>
+          <a:p>
+            <a:pPr indent="0" marL="0">
+              <a:buNone/>
+            </a:pPr>
+            <a:r>
+              <a:rPr lang="en-US" sz="1000" b="1" spc="300" kern="0" dirty="0">
+                <a:solidFill>
+                  <a:srgbClr val="75948A"/>
+                </a:solidFill>
+                <a:latin typeface="Calibri" pitchFamily="34" charset="0"/>
+                <a:ea typeface="Calibri" pitchFamily="34" charset="-122"/>
+                <a:cs typeface="Calibri" pitchFamily="34" charset="-120"/>
+              </a:rPr>
+              <a:t/>
+            </a:r>
+            <a:endParaRPr lang="en-US" sz="1000" dirty="0"/>
+          </a:p>
+        </p:txBody>
+      </p:sp>
+      <p:sp>
+        <p:nvSpPr>
+          <p:cNvPr id="8" name="Text 6"/>
+          <p:cNvSpPr/>
+          <p:nvPr/>
+        </p:nvSpPr>
+        <p:spPr>
+          <a:xfrm>
+            <a:off x="640080" y="1801368"/>
+            <a:ext cx="3657600" cy="411480"/>
+          </a:xfrm>
+          <a:prstGeom prst="rect">
+            <a:avLst/>
+          </a:prstGeom>
+          <a:noFill/>
+          <a:ln/>
+        </p:spPr>
+        <p:txBody>
+          <a:bodyPr wrap="square" lIns="0" tIns="0" rIns="0" bIns="0" rtlCol="0" anchor="t"/>
+          <a:lstStyle/>
+          <a:p>
+            <a:pPr indent="0" marL="0">
+              <a:buNone/>
+            </a:pPr>
+            <a:r>
+              <a:rPr lang="en-US" sz="1250" dirty="0">
+                <a:solidFill>
+                  <a:srgbClr val="2D3142"/>
+                </a:solidFill>
+                <a:latin typeface="Calibri" pitchFamily="34" charset="0"/>
+                <a:ea typeface="Calibri" pitchFamily="34" charset="-122"/>
+                <a:cs typeface="Calibri" pitchFamily="34" charset="-120"/>
+              </a:rPr>
+              <a:t/>
+            </a:r>
+            <a:endParaRPr lang="en-US" sz="1250" dirty="0"/>
+          </a:p>
+        </p:txBody>
+      </p:sp>
+      <p:sp>
+        <p:nvSpPr>
+          <p:cNvPr id="9" name="Shape 7"/>
+          <p:cNvSpPr/>
+          <p:nvPr/>
+        </p:nvSpPr>
+        <p:spPr>
+          <a:xfrm>
+            <a:off x="457200" y="2377440"/>
+            <a:ext cx="3931920" cy="1463040"/>
+          </a:xfrm>
+          <a:prstGeom prst="rect">
+            <a:avLst/>
+          </a:prstGeom>
+          <a:solidFill>
+            <a:srgbClr val="EDE6D6"/>
+          </a:solidFill>
+          <a:ln w="12700">
+            <a:solidFill>
+              <a:srgbClr val="EDE6D6"/>
+            </a:solidFill>
+            <a:prstDash val="solid"/>
+          </a:ln>
+        </p:spPr>
+        <p:txBody>
+          <a:bodyPr/>
+          <a:p>
+            <a:r>
+              <a:rPr>
+                <a:solidFill/>
+              </a:rPr>
+              <a:t>1-channel uint8 → 3-channel float tensor in [0, 1]</a:t>
+            </a:r>
+          </a:p>
+          <a:p>
+            <a:r>
+              <a:rPr b="0"/>
+              <a:t>ImageNet mean/std normalisation</a:t>
+            </a:r>
+          </a:p>
+          <a:p>
+            <a:r>
+              <a:rPr b="0"/>
+              <a:t/>
+            </a:r>
+          </a:p>
+          <a:p>
+            <a:r>
+              <a:rPr b="0"/>
+              <a:t>Train-only augmentations:</a:t>
+            </a:r>
+          </a:p>
+          <a:p>
+            <a:r>
+              <a:rPr b="0"/>
+              <a:t>  RandomHorizontalFlip(p=0.5)</a:t>
+            </a:r>
+          </a:p>
+          <a:p>
+            <a:r>
+              <a:rPr b="0"/>
+              <a:t>  RandomAffine(degrees=15)</a:t>
+            </a:r>
+          </a:p>
+          <a:p>
+            <a:r>
+              <a:rPr b="0"/>
+              <a:t>  RandomResizedCrop scale=(0.9, 1.0)</a:t>
+            </a:r>
+          </a:p>
+          <a:p>
+            <a:r>
+              <a:rPr b="0"/>
+              <a:t>  ColorJitter brightness/contrast 0.1</a:t>
+            </a:r>
+          </a:p>
+          <a:p>
+            <a:r>
+              <a:rPr b="0"/>
+              <a:t/>
+            </a:r>
+          </a:p>
+          <a:p>
+            <a:r>
+              <a:rPr b="0"/>
+              <a:t>Val/test transforms are deterministic</a:t>
+            </a:r>
+          </a:p>
+          <a:p>
+            <a:r>
+              <a:rPr b="0"/>
+              <a:t>(resize + normalise only)</a:t>
+            </a:r>
+          </a:p>
+        </p:txBody>
+      </p:sp>
+      <p:sp>
+        <p:nvSpPr>
+          <p:cNvPr id="10" name="Shape 8"/>
+          <p:cNvSpPr/>
+          <p:nvPr/>
+        </p:nvSpPr>
+        <p:spPr>
+          <a:xfrm>
+            <a:off x="457200" y="2377440"/>
+            <a:ext cx="91440" cy="1463040"/>
+          </a:xfrm>
+          <a:prstGeom prst="rect">
+            <a:avLst/>
+          </a:prstGeom>
+          <a:solidFill>
+            <a:srgbClr val="B85042"/>
+          </a:solidFill>
+          <a:ln w="12700">
+            <a:solidFill>
+              <a:srgbClr val="B85042"/>
+            </a:solidFill>
+            <a:prstDash val="solid"/>
+          </a:ln>
+        </p:spPr>
+        <p:txBody>
+          <a:bodyPr/>
+          <a:p>
+            <a:r>
+              <a:t/>
+            </a:r>
+          </a:p>
+        </p:txBody>
+      </p:sp>
+      <p:sp>
+        <p:nvSpPr>
+          <p:cNvPr id="11" name="Text 9"/>
+          <p:cNvSpPr/>
+          <p:nvPr/>
+        </p:nvSpPr>
+        <p:spPr>
+          <a:xfrm>
+            <a:off x="640080" y="2423160"/>
+            <a:ext cx="3657600" cy="228600"/>
+          </a:xfrm>
+          <a:prstGeom prst="rect">
+            <a:avLst/>
+          </a:prstGeom>
+          <a:noFill/>
+          <a:ln/>
+        </p:spPr>
+        <p:txBody>
+          <a:bodyPr wrap="square" lIns="0" tIns="0" rIns="0" bIns="0" rtlCol="0" anchor="t"/>
+          <a:lstStyle/>
+          <a:p>
+            <a:pPr indent="0" marL="0">
+              <a:buNone/>
+            </a:pPr>
+            <a:r>
+              <a:rPr lang="en-US" sz="1000" b="1" spc="300" kern="0" dirty="0">
+                <a:solidFill>
+                  <a:srgbClr val="B85042"/>
+                </a:solidFill>
+                <a:latin typeface="Calibri" pitchFamily="34" charset="0"/>
+                <a:ea typeface="Calibri" pitchFamily="34" charset="-122"/>
+                <a:cs typeface="Calibri" pitchFamily="34" charset="-120"/>
+              </a:rPr>
+              <a:t/>
+            </a:r>
+            <a:endParaRPr lang="en-US" sz="1000" dirty="0"/>
+          </a:p>
+        </p:txBody>
+      </p:sp>
+      <p:sp>
+        <p:nvSpPr>
+          <p:cNvPr id="12" name="Text 10"/>
+          <p:cNvSpPr/>
+          <p:nvPr/>
+        </p:nvSpPr>
+        <p:spPr>
+          <a:xfrm>
+            <a:off x="640080" y="2651760"/>
+            <a:ext cx="3657600" cy="1280160"/>
+          </a:xfrm>
+          <a:prstGeom prst="rect">
+            <a:avLst/>
+          </a:prstGeom>
+          <a:noFill/>
+          <a:ln/>
+        </p:spPr>
+        <p:txBody>
+          <a:bodyPr wrap="square" lIns="0" tIns="0" rIns="0" bIns="0" rtlCol="0" anchor="t"/>
+          <a:lstStyle/>
+          <a:p>
+            <a:pPr indent="0" marL="0">
+              <a:spcAft>
+                <a:spcPts val="200"/>
+              </a:spcAft>
+              <a:buNone/>
+            </a:pPr>
+            <a:r>
+              <a:rPr lang="en-US" sz="1150" dirty="0">
+                <a:solidFill>
+                  <a:srgbClr val="2D3142"/>
+                </a:solidFill>
+                <a:latin typeface="Calibri" pitchFamily="34" charset="0"/>
+                <a:ea typeface="Calibri" pitchFamily="34" charset="-122"/>
+                <a:cs typeface="Calibri" pitchFamily="34" charset="-120"/>
+              </a:rPr>
+              <a:t/>
+            </a:r>
+            <a:endParaRPr lang="en-US" sz="1150" dirty="0"/>
+          </a:p>
+        </p:txBody>
+      </p:sp>
+      <p:sp>
+        <p:nvSpPr>
+          <p:cNvPr id="13" name="Text 11"/>
+          <p:cNvSpPr/>
+          <p:nvPr/>
+        </p:nvSpPr>
+        <p:spPr>
+          <a:xfrm>
+            <a:off x="457200" y="3977640"/>
+            <a:ext cx="3931920" cy="548640"/>
+          </a:xfrm>
+          <a:prstGeom prst="rect">
+            <a:avLst/>
+          </a:prstGeom>
+          <a:noFill/>
+          <a:ln/>
+        </p:spPr>
+        <p:txBody>
+          <a:bodyPr wrap="square" lIns="0" tIns="0" rIns="0" bIns="0" rtlCol="0" anchor="t"/>
+          <a:lstStyle/>
+          <a:p>
+            <a:pPr indent="0" marL="0">
+              <a:spcAft>
+                <a:spcPts val="200"/>
+              </a:spcAft>
+              <a:buNone/>
+            </a:pPr>
+            <a:r>
+              <a:rPr lang="en-US" sz="1150" b="1" dirty="0">
+                <a:solidFill>
+                  <a:srgbClr val="B85042"/>
+                </a:solidFill>
+                <a:latin typeface="Calibri" pitchFamily="34" charset="0"/>
+                <a:ea typeface="Calibri" pitchFamily="34" charset="-122"/>
+                <a:cs typeface="Calibri" pitchFamily="34" charset="-120"/>
+              </a:rPr>
+              <a:t/>
+            </a:r>
+            <a:pPr indent="0" marL="0">
+              <a:spcAft>
+                <a:spcPts val="200"/>
+              </a:spcAft>
+              <a:buNone/>
+            </a:pPr>
+            <a:endParaRPr lang="en-US" sz="1150" dirty="0"/>
+          </a:p>
+        </p:txBody>
+      </p:sp>
+      <p:sp>
+        <p:nvSpPr>
+          <p:cNvPr id="14" name="Text 12"/>
+          <p:cNvSpPr/>
+          <p:nvPr/>
+        </p:nvSpPr>
+        <p:spPr>
+          <a:xfrm>
+            <a:off x="4572000" y="1143000"/>
+            <a:ext cx="4389120" cy="292608"/>
+          </a:xfrm>
+          <a:prstGeom prst="rect">
+            <a:avLst/>
+          </a:prstGeom>
+          <a:noFill/>
+          <a:ln/>
+        </p:spPr>
+        <p:txBody>
+          <a:bodyPr wrap="square" lIns="0" tIns="0" rIns="0" bIns="0" rtlCol="0" anchor="t"/>
+          <a:lstStyle/>
+          <a:p>
+            <a:pPr indent="0" marL="0">
+              <a:buNone/>
+            </a:pPr>
+            <a:r>
+              <a:rPr lang="en-US" sz="1500" b="1" dirty="0">
+                <a:solidFill>
+                  <a:srgbClr val="B85042"/>
+                </a:solidFill>
+                <a:latin typeface="Calibri" pitchFamily="34" charset="0"/>
+                <a:ea typeface="Calibri" pitchFamily="34" charset="-122"/>
+                <a:cs typeface="Calibri" pitchFamily="34" charset="-120"/>
+              </a:rPr>
+              <a:t>Code  ·  deep_learning/dataset.py</a:t>
+            </a:r>
+            <a:endParaRPr lang="en-US" sz="1500" dirty="0"/>
+          </a:p>
+        </p:txBody>
+      </p:sp>
+      <p:sp>
+        <p:nvSpPr>
+          <p:cNvPr id="15" name="Shape 13"/>
+          <p:cNvSpPr/>
+          <p:nvPr/>
+        </p:nvSpPr>
+        <p:spPr>
+          <a:xfrm>
+            <a:off x="4572000" y="1508760"/>
+            <a:ext cx="4389120" cy="3383280"/>
+          </a:xfrm>
+          <a:prstGeom prst="rect">
+            <a:avLst/>
+          </a:prstGeom>
+          <a:solidFill>
+            <a:srgbClr val="1E293B"/>
+          </a:solidFill>
+          <a:ln w="12700">
+            <a:solidFill>
+              <a:srgbClr val="1E293B"/>
+            </a:solidFill>
+            <a:prstDash val="solid"/>
+          </a:ln>
+        </p:spPr>
+        <p:txBody>
+          <a:bodyPr/>
+          <a:p>
+            <a:r>
+              <a:t/>
+            </a:r>
+          </a:p>
+        </p:txBody>
+      </p:sp>
+      <p:sp>
+        <p:nvSpPr>
+          <p:cNvPr id="16" name="Text 14"/>
+          <p:cNvSpPr/>
+          <p:nvPr/>
+        </p:nvSpPr>
+        <p:spPr>
+          <a:xfrm>
+            <a:off x="4709160" y="1600200"/>
+            <a:ext cx="4114800" cy="3200400"/>
+          </a:xfrm>
+          <a:prstGeom prst="rect">
+            <a:avLst/>
+          </a:prstGeom>
+          <a:noFill/>
+          <a:ln/>
+        </p:spPr>
+        <p:txBody>
+          <a:bodyPr wrap="square" lIns="0" tIns="0" rIns="0" bIns="0" rtlCol="0" anchor="t"/>
+          <a:lstStyle/>
+          <a:p>
+            <a:pPr indent="0" marL="0">
+              <a:buNone/>
+            </a:pPr>
+            <a:r>
+              <a:rPr lang="en-US" sz="1050" dirty="0">
+                <a:solidFill>
+                  <a:srgbClr val="F0B27A"/>
+                </a:solidFill>
+                <a:latin typeface="Courier New" pitchFamily="34" charset="0"/>
+                <a:ea typeface="Courier New" pitchFamily="34" charset="-122"/>
+                <a:cs typeface="Courier New" pitchFamily="34" charset="-120"/>
+              </a:rPr>
+              <a:t>def _to_3channel_tensor(arr):</a:t>
+            </a:r>
+            <a:pPr indent="0" marL="0">
+              <a:buNone/>
+            </a:pPr>
+            <a:endParaRPr lang="en-US" sz="1050" dirty="0"/>
+          </a:p>
+          <a:p>
+            <a:r>
+              <a:rPr sz="1050" b="0">
+                <a:solidFill>
+                  <a:srgbClr val="F0B27A"/>
+                </a:solidFill>
+                <a:latin typeface="Courier New"/>
+              </a:rPr>
+              <a:t>    t = torch.tensor(arr, dtype=torch.float32) / 255.0</a:t>
+            </a:r>
+          </a:p>
+          <a:p>
+            <a:r>
+              <a:rPr sz="1050" b="0">
+                <a:solidFill>
+                  <a:srgbClr val="F0B27A"/>
+                </a:solidFill>
+                <a:latin typeface="Courier New"/>
+              </a:rPr>
+              <a:t>    return t.unsqueeze(0).repeat(3, 1, 1)</a:t>
+            </a:r>
+          </a:p>
+          <a:p>
+            <a:r>
+              <a:rPr sz="1050" b="0">
+                <a:solidFill>
+                  <a:srgbClr val="F0B27A"/>
+                </a:solidFill>
+                <a:latin typeface="Courier New"/>
+              </a:rPr>
+              <a:t/>
+            </a:r>
+          </a:p>
+          <a:p>
+            <a:r>
+              <a:rPr sz="1050" b="0">
+                <a:solidFill>
+                  <a:srgbClr val="F0B27A"/>
+                </a:solidFill>
+                <a:latin typeface="Courier New"/>
+              </a:rPr>
+              <a:t>def build_transforms(train, image_size=224):</a:t>
+            </a:r>
+          </a:p>
+          <a:p>
+            <a:r>
+              <a:rPr sz="1050" b="0">
+                <a:solidFill>
+                  <a:srgbClr val="F0B27A"/>
+                </a:solidFill>
+                <a:latin typeface="Courier New"/>
+              </a:rPr>
+              <a:t>    if train:</a:t>
+            </a:r>
+          </a:p>
+          <a:p>
+            <a:r>
+              <a:rPr sz="1050" b="0">
+                <a:solidFill>
+                  <a:srgbClr val="F0B27A"/>
+                </a:solidFill>
+                <a:latin typeface="Courier New"/>
+              </a:rPr>
+              <a:t>        return transforms.Compose([</a:t>
+            </a:r>
+          </a:p>
+          <a:p>
+            <a:r>
+              <a:rPr sz="1050" b="0">
+                <a:solidFill>
+                  <a:srgbClr val="F0B27A"/>
+                </a:solidFill>
+                <a:latin typeface="Courier New"/>
+              </a:rPr>
+              <a:t>            transforms.Lambda(_to_3channel_tensor),</a:t>
+            </a:r>
+          </a:p>
+          <a:p>
+            <a:r>
+              <a:rPr sz="1050" b="0">
+                <a:solidFill>
+                  <a:srgbClr val="F0B27A"/>
+                </a:solidFill>
+                <a:latin typeface="Courier New"/>
+              </a:rPr>
+              <a:t>            transforms.RandomHorizontalFlip(p=0.5),</a:t>
+            </a:r>
+          </a:p>
+          <a:p>
+            <a:r>
+              <a:rPr sz="1050" b="0">
+                <a:solidFill>
+                  <a:srgbClr val="F0B27A"/>
+                </a:solidFill>
+                <a:latin typeface="Courier New"/>
+              </a:rPr>
+              <a:t>            transforms.RandomAffine(degrees=15),</a:t>
+            </a:r>
+          </a:p>
+          <a:p>
+            <a:r>
+              <a:rPr sz="1050" b="0">
+                <a:solidFill>
+                  <a:srgbClr val="F0B27A"/>
+                </a:solidFill>
+                <a:latin typeface="Courier New"/>
+              </a:rPr>
+              <a:t>            transforms.RandomResizedCrop(</a:t>
+            </a:r>
+          </a:p>
+          <a:p>
+            <a:r>
+              <a:rPr sz="1050" b="0">
+                <a:solidFill>
+                  <a:srgbClr val="F0B27A"/>
+                </a:solidFill>
+                <a:latin typeface="Courier New"/>
+              </a:rPr>
+              <a:t>                image_size, scale=(0.9, 1.0)),</a:t>
+            </a:r>
+          </a:p>
+          <a:p>
+            <a:r>
+              <a:rPr sz="1050" b="0">
+                <a:solidFill>
+                  <a:srgbClr val="F0B27A"/>
+                </a:solidFill>
+                <a:latin typeface="Courier New"/>
+              </a:rPr>
+              <a:t>            transforms.ColorJitter(0.1, 0.1),</a:t>
+            </a:r>
+          </a:p>
+          <a:p>
+            <a:r>
+              <a:rPr sz="1050" b="0">
+                <a:solidFill>
+                  <a:srgbClr val="F0B27A"/>
+                </a:solidFill>
+                <a:latin typeface="Courier New"/>
+              </a:rPr>
+              <a:t>            transforms.Normalize(</a:t>
+            </a:r>
+          </a:p>
+          <a:p>
+            <a:r>
+              <a:rPr sz="1050" b="0">
+                <a:solidFill>
+                  <a:srgbClr val="F0B27A"/>
+                </a:solidFill>
+                <a:latin typeface="Courier New"/>
+              </a:rPr>
+              <a:t>                IMAGENET_MEAN, IMAGENET_STD),</a:t>
+            </a:r>
+          </a:p>
+          <a:p>
+            <a:r>
+              <a:rPr sz="1050" b="0">
+                <a:solidFill>
+                  <a:srgbClr val="F0B27A"/>
+                </a:solidFill>
+                <a:latin typeface="Courier New"/>
+              </a:rPr>
+              <a:t>        ])</a:t>
+            </a:r>
+          </a:p>
+          <a:p>
+            <a:r>
+              <a:rPr sz="1050" b="0">
+                <a:solidFill>
+                  <a:srgbClr val="F0B27A"/>
+                </a:solidFill>
+                <a:latin typeface="Courier New"/>
+              </a:rPr>
+              <a:t>    # eval branch: resize + normalise only</a:t>
+            </a:r>
+          </a:p>
+        </p:txBody>
+      </p:sp>
+    </p:spTree>
+  </p:cSld>
+  <p:clrMapOvr>
+    <a:masterClrMapping/>
+  </p:clrMapOvr>
+</p:sld>
+</file>
+
+<file path=ppt/slides/slide12.xml><?xml version="1.0" encoding="utf-8"?>
+<p:sld xmlns:a="http://schemas.openxmlformats.org/drawingml/2006/main" xmlns:p="http://schemas.openxmlformats.org/presentationml/2006/main" xmlns:r="http://schemas.openxmlformats.org/officeDocument/2006/relationships">
+  <p:cSld>
+    <p:spTree>
+      <p:nvGrpSpPr>
+        <p:cNvPr id="1" name=""/>
+        <p:cNvGrpSpPr/>
+        <p:nvPr/>
+      </p:nvGrpSpPr>
+      <p:grpSpPr/>
+      <p:sp>
+        <p:nvSpPr>
+          <p:cNvPr id="2" name="Text 0"/>
+          <p:cNvSpPr/>
+          <p:nvPr/>
+        </p:nvSpPr>
+        <p:spPr>
+          <a:xfrm>
+            <a:off x="457200" y="292608"/>
+            <a:ext cx="7772400" cy="502920"/>
+          </a:xfrm>
+          <a:prstGeom prst="rect">
+            <a:avLst/>
+          </a:prstGeom>
+          <a:noFill/>
+          <a:ln/>
+        </p:spPr>
+        <p:txBody>
+          <a:bodyPr wrap="square" lIns="0" tIns="0" rIns="0" bIns="0" rtlCol="0" anchor="t"/>
+          <a:lstStyle/>
+          <a:p>
+            <a:pPr indent="0" marL="0">
+              <a:buNone/>
+            </a:pPr>
+            <a:r>
+              <a:rPr lang="en-US" sz="2800" b="1" dirty="0">
+                <a:solidFill>
+                  <a:srgbClr val="2D3142"/>
+                </a:solidFill>
+                <a:latin typeface="Calibri" pitchFamily="34" charset="0"/>
+                <a:ea typeface="Calibri" pitchFamily="34" charset="-122"/>
+                <a:cs typeface="Calibri" pitchFamily="34" charset="-120"/>
+              </a:rPr>
+              <a:t>DL Model Builders  ·  freeze + unfreeze</a:t>
+            </a:r>
+            <a:endParaRPr lang="en-US" sz="2800" dirty="0"/>
+          </a:p>
+        </p:txBody>
+      </p:sp>
+      <p:sp>
+        <p:nvSpPr>
+          <p:cNvPr id="3" name="Text 1"/>
+          <p:cNvSpPr/>
+          <p:nvPr/>
+        </p:nvSpPr>
+        <p:spPr>
+          <a:xfrm>
+            <a:off x="5943600" y="292608"/>
+            <a:ext cx="2834640" cy="292608"/>
+          </a:xfrm>
+          <a:prstGeom prst="rect">
+            <a:avLst/>
+          </a:prstGeom>
+          <a:noFill/>
+          <a:ln/>
+        </p:spPr>
+        <p:txBody>
+          <a:bodyPr wrap="square" lIns="0" tIns="0" rIns="0" bIns="0" rtlCol="0" anchor="t"/>
+          <a:lstStyle/>
+          <a:p>
+            <a:pPr algn="r" indent="0" marL="0">
+              <a:buNone/>
+            </a:pPr>
+            <a:r>
+              <a:rPr lang="en-US" sz="900" b="1" spc="400" kern="0" dirty="0">
+                <a:solidFill>
+                  <a:srgbClr val="75948A"/>
+                </a:solidFill>
+                <a:latin typeface="Calibri" pitchFamily="34" charset="0"/>
+                <a:ea typeface="Calibri" pitchFamily="34" charset="-122"/>
+                <a:cs typeface="Calibri" pitchFamily="34" charset="-120"/>
+              </a:rPr>
+              <a:t>METHODS · DEEP LEARNING · JAMES</a:t>
+            </a:r>
+            <a:endParaRPr lang="en-US" sz="900" dirty="0"/>
+          </a:p>
+        </p:txBody>
+      </p:sp>
+      <p:sp>
+        <p:nvSpPr>
+          <p:cNvPr id="4" name="Text 2"/>
+          <p:cNvSpPr/>
+          <p:nvPr/>
+        </p:nvSpPr>
+        <p:spPr>
+          <a:xfrm>
+            <a:off x="457200" y="1143000"/>
+            <a:ext cx="3931920" cy="292608"/>
+          </a:xfrm>
+          <a:prstGeom prst="rect">
+            <a:avLst/>
+          </a:prstGeom>
+          <a:noFill/>
+          <a:ln/>
+        </p:spPr>
+        <p:txBody>
+          <a:bodyPr wrap="square" lIns="0" tIns="0" rIns="0" bIns="0" rtlCol="0" anchor="t"/>
+          <a:lstStyle/>
+          <a:p>
+            <a:pPr indent="0" marL="0">
+              <a:buNone/>
+            </a:pPr>
+            <a:r>
+              <a:rPr lang="en-US" sz="1500" b="1" dirty="0">
+                <a:solidFill>
+                  <a:srgbClr val="B85042"/>
+                </a:solidFill>
+                <a:latin typeface="Calibri" pitchFamily="34" charset="0"/>
+                <a:ea typeface="Calibri" pitchFamily="34" charset="-122"/>
+                <a:cs typeface="Calibri" pitchFamily="34" charset="-120"/>
+              </a:rPr>
+              <a:t>Two backbones, one dispatcher</a:t>
+            </a:r>
+            <a:endParaRPr lang="en-US" sz="1500" dirty="0"/>
+          </a:p>
+        </p:txBody>
+      </p:sp>
+      <p:sp>
+        <p:nvSpPr>
+          <p:cNvPr id="5" name="Shape 3"/>
+          <p:cNvSpPr/>
+          <p:nvPr/>
+        </p:nvSpPr>
+        <p:spPr>
+          <a:xfrm>
+            <a:off x="457200" y="1508760"/>
+            <a:ext cx="3931920" cy="777240"/>
+          </a:xfrm>
+          <a:prstGeom prst="rect">
+            <a:avLst/>
+          </a:prstGeom>
+          <a:solidFill>
+            <a:srgbClr val="EDE6D6"/>
+          </a:solidFill>
+          <a:ln w="12700">
+            <a:solidFill>
+              <a:srgbClr val="EDE6D6"/>
+            </a:solidFill>
+            <a:prstDash val="solid"/>
+          </a:ln>
+        </p:spPr>
+        <p:txBody>
+          <a:bodyPr/>
+          <a:p>
+            <a:r>
+              <a:t/>
+            </a:r>
+          </a:p>
+        </p:txBody>
+      </p:sp>
+      <p:sp>
+        <p:nvSpPr>
+          <p:cNvPr id="6" name="Shape 4"/>
+          <p:cNvSpPr/>
+          <p:nvPr/>
+        </p:nvSpPr>
+        <p:spPr>
+          <a:xfrm>
+            <a:off x="457200" y="1508760"/>
+            <a:ext cx="91440" cy="777240"/>
+          </a:xfrm>
+          <a:prstGeom prst="rect">
+            <a:avLst/>
+          </a:prstGeom>
+          <a:solidFill>
+            <a:srgbClr val="75948A"/>
+          </a:solidFill>
+          <a:ln w="12700">
+            <a:solidFill>
+              <a:srgbClr val="75948A"/>
+            </a:solidFill>
+            <a:prstDash val="solid"/>
+          </a:ln>
+        </p:spPr>
+        <p:txBody>
+          <a:bodyPr/>
+          <a:p>
+            <a:r>
+              <a:t/>
+            </a:r>
+          </a:p>
+        </p:txBody>
+      </p:sp>
+      <p:sp>
+        <p:nvSpPr>
+          <p:cNvPr id="7" name="Text 5"/>
+          <p:cNvSpPr/>
+          <p:nvPr/>
+        </p:nvSpPr>
+        <p:spPr>
+          <a:xfrm>
+            <a:off x="640080" y="1554480"/>
+            <a:ext cx="3657600" cy="228600"/>
+          </a:xfrm>
+          <a:prstGeom prst="rect">
+            <a:avLst/>
+          </a:prstGeom>
+          <a:noFill/>
+          <a:ln/>
+        </p:spPr>
+        <p:txBody>
+          <a:bodyPr wrap="square" lIns="0" tIns="0" rIns="0" bIns="0" rtlCol="0" anchor="t"/>
+          <a:lstStyle/>
+          <a:p>
+            <a:pPr indent="0" marL="0">
+              <a:buNone/>
+            </a:pPr>
+            <a:r>
+              <a:rPr lang="en-US" sz="1000" b="1" spc="300" kern="0" dirty="0">
+                <a:solidFill>
+                  <a:srgbClr val="75948A"/>
+                </a:solidFill>
+                <a:latin typeface="Calibri" pitchFamily="34" charset="0"/>
+                <a:ea typeface="Calibri" pitchFamily="34" charset="-122"/>
+                <a:cs typeface="Calibri" pitchFamily="34" charset="-120"/>
+              </a:rPr>
+              <a:t/>
+            </a:r>
+            <a:endParaRPr lang="en-US" sz="1000" dirty="0"/>
+          </a:p>
+        </p:txBody>
+      </p:sp>
+      <p:sp>
+        <p:nvSpPr>
+          <p:cNvPr id="8" name="Text 6"/>
+          <p:cNvSpPr/>
+          <p:nvPr/>
+        </p:nvSpPr>
+        <p:spPr>
+          <a:xfrm>
+            <a:off x="640080" y="1801368"/>
+            <a:ext cx="3657600" cy="411480"/>
+          </a:xfrm>
+          <a:prstGeom prst="rect">
+            <a:avLst/>
+          </a:prstGeom>
+          <a:noFill/>
+          <a:ln/>
+        </p:spPr>
+        <p:txBody>
+          <a:bodyPr wrap="square" lIns="0" tIns="0" rIns="0" bIns="0" rtlCol="0" anchor="t"/>
+          <a:lstStyle/>
+          <a:p>
+            <a:pPr indent="0" marL="0">
+              <a:buNone/>
+            </a:pPr>
+            <a:r>
+              <a:rPr lang="en-US" sz="1250" dirty="0">
+                <a:solidFill>
+                  <a:srgbClr val="2D3142"/>
+                </a:solidFill>
+                <a:latin typeface="Calibri" pitchFamily="34" charset="0"/>
+                <a:ea typeface="Calibri" pitchFamily="34" charset="-122"/>
+                <a:cs typeface="Calibri" pitchFamily="34" charset="-120"/>
+              </a:rPr>
+              <a:t/>
+            </a:r>
+            <a:endParaRPr lang="en-US" sz="1250" dirty="0"/>
+          </a:p>
+        </p:txBody>
+      </p:sp>
+      <p:sp>
+        <p:nvSpPr>
+          <p:cNvPr id="9" name="Shape 7"/>
+          <p:cNvSpPr/>
+          <p:nvPr/>
+        </p:nvSpPr>
+        <p:spPr>
+          <a:xfrm>
+            <a:off x="457200" y="2377440"/>
+            <a:ext cx="3931920" cy="1463040"/>
+          </a:xfrm>
+          <a:prstGeom prst="rect">
+            <a:avLst/>
+          </a:prstGeom>
+          <a:solidFill>
+            <a:srgbClr val="EDE6D6"/>
+          </a:solidFill>
+          <a:ln w="12700">
+            <a:solidFill>
+              <a:srgbClr val="EDE6D6"/>
+            </a:solidFill>
+            <a:prstDash val="solid"/>
+          </a:ln>
+        </p:spPr>
+        <p:txBody>
+          <a:bodyPr/>
+          <a:p>
+            <a:r>
+              <a:rPr>
+                <a:solidFill/>
+              </a:rPr>
+              <a:t>EfficientNet-B0 (torchvision)</a:t>
+            </a:r>
+          </a:p>
+          <a:p>
+            <a:r>
+              <a:rPr b="0"/>
+              <a:t>  ImageNet-1k weights, classifier head replaced</a:t>
+            </a:r>
+          </a:p>
+          <a:p>
+            <a:r>
+              <a:rPr b="0"/>
+              <a:t/>
+            </a:r>
+          </a:p>
+          <a:p>
+            <a:r>
+              <a:rPr b="0"/>
+              <a:t>ConvNeXt V2 Base (timm)</a:t>
+            </a:r>
+          </a:p>
+          <a:p>
+            <a:r>
+              <a:rPr b="0"/>
+              <a:t>  fcmae_ft_in22k_in1k_384 weights</a:t>
+            </a:r>
+          </a:p>
+          <a:p>
+            <a:r>
+              <a:rPr b="0"/>
+              <a:t>  drop_path_rate=0.3, drop_rate=0.3</a:t>
+            </a:r>
+          </a:p>
+          <a:p>
+            <a:r>
+              <a:rPr b="0"/>
+              <a:t/>
+            </a:r>
+          </a:p>
+          <a:p>
+            <a:r>
+              <a:rPr b="0"/>
+              <a:t>Freeze logic is backbone-aware:</a:t>
+            </a:r>
+          </a:p>
+          <a:p>
+            <a:r>
+              <a:rPr b="0"/>
+              <a:t>  EffNet stages live in model.features</a:t>
+            </a:r>
+          </a:p>
+          <a:p>
+            <a:r>
+              <a:rPr b="0"/>
+              <a:t>  ConvNeXt stages live in model.stages</a:t>
+            </a:r>
+          </a:p>
+          <a:p>
+            <a:r>
+              <a:rPr b="0"/>
+              <a:t>Stage 1 freezes all backbone params</a:t>
+            </a:r>
+          </a:p>
+        </p:txBody>
+      </p:sp>
+      <p:sp>
+        <p:nvSpPr>
+          <p:cNvPr id="10" name="Shape 8"/>
+          <p:cNvSpPr/>
+          <p:nvPr/>
+        </p:nvSpPr>
+        <p:spPr>
+          <a:xfrm>
+            <a:off x="457200" y="2377440"/>
+            <a:ext cx="91440" cy="1463040"/>
+          </a:xfrm>
+          <a:prstGeom prst="rect">
+            <a:avLst/>
+          </a:prstGeom>
+          <a:solidFill>
+            <a:srgbClr val="B85042"/>
+          </a:solidFill>
+          <a:ln w="12700">
+            <a:solidFill>
+              <a:srgbClr val="B85042"/>
+            </a:solidFill>
+            <a:prstDash val="solid"/>
+          </a:ln>
+        </p:spPr>
+        <p:txBody>
+          <a:bodyPr/>
+          <a:p>
+            <a:r>
+              <a:t/>
+            </a:r>
+          </a:p>
+        </p:txBody>
+      </p:sp>
+      <p:sp>
+        <p:nvSpPr>
+          <p:cNvPr id="11" name="Text 9"/>
+          <p:cNvSpPr/>
+          <p:nvPr/>
+        </p:nvSpPr>
+        <p:spPr>
+          <a:xfrm>
+            <a:off x="640080" y="2423160"/>
+            <a:ext cx="3657600" cy="228600"/>
+          </a:xfrm>
+          <a:prstGeom prst="rect">
+            <a:avLst/>
+          </a:prstGeom>
+          <a:noFill/>
+          <a:ln/>
+        </p:spPr>
+        <p:txBody>
+          <a:bodyPr wrap="square" lIns="0" tIns="0" rIns="0" bIns="0" rtlCol="0" anchor="t"/>
+          <a:lstStyle/>
+          <a:p>
+            <a:pPr indent="0" marL="0">
+              <a:buNone/>
+            </a:pPr>
+            <a:r>
+              <a:rPr lang="en-US" sz="1000" b="1" spc="300" kern="0" dirty="0">
+                <a:solidFill>
+                  <a:srgbClr val="B85042"/>
+                </a:solidFill>
+                <a:latin typeface="Calibri" pitchFamily="34" charset="0"/>
+                <a:ea typeface="Calibri" pitchFamily="34" charset="-122"/>
+                <a:cs typeface="Calibri" pitchFamily="34" charset="-120"/>
+              </a:rPr>
+              <a:t/>
+            </a:r>
+            <a:endParaRPr lang="en-US" sz="1000" dirty="0"/>
+          </a:p>
+        </p:txBody>
+      </p:sp>
+      <p:sp>
+        <p:nvSpPr>
+          <p:cNvPr id="12" name="Text 10"/>
+          <p:cNvSpPr/>
+          <p:nvPr/>
+        </p:nvSpPr>
+        <p:spPr>
+          <a:xfrm>
+            <a:off x="640080" y="2651760"/>
+            <a:ext cx="3657600" cy="1280160"/>
+          </a:xfrm>
+          <a:prstGeom prst="rect">
+            <a:avLst/>
+          </a:prstGeom>
+          <a:noFill/>
+          <a:ln/>
+        </p:spPr>
+        <p:txBody>
+          <a:bodyPr wrap="square" lIns="0" tIns="0" rIns="0" bIns="0" rtlCol="0" anchor="t"/>
+          <a:lstStyle/>
+          <a:p>
+            <a:pPr indent="0" marL="0">
+              <a:spcAft>
+                <a:spcPts val="200"/>
+              </a:spcAft>
+              <a:buNone/>
+            </a:pPr>
+            <a:r>
+              <a:rPr lang="en-US" sz="1150" dirty="0">
+                <a:solidFill>
+                  <a:srgbClr val="2D3142"/>
+                </a:solidFill>
+                <a:latin typeface="Calibri" pitchFamily="34" charset="0"/>
+                <a:ea typeface="Calibri" pitchFamily="34" charset="-122"/>
+                <a:cs typeface="Calibri" pitchFamily="34" charset="-120"/>
+              </a:rPr>
+              <a:t/>
+            </a:r>
+            <a:endParaRPr lang="en-US" sz="1150" dirty="0"/>
+          </a:p>
+        </p:txBody>
+      </p:sp>
+      <p:sp>
+        <p:nvSpPr>
+          <p:cNvPr id="13" name="Text 11"/>
+          <p:cNvSpPr/>
+          <p:nvPr/>
+        </p:nvSpPr>
+        <p:spPr>
+          <a:xfrm>
+            <a:off x="457200" y="3977640"/>
+            <a:ext cx="3931920" cy="548640"/>
+          </a:xfrm>
+          <a:prstGeom prst="rect">
+            <a:avLst/>
+          </a:prstGeom>
+          <a:noFill/>
+          <a:ln/>
+        </p:spPr>
+        <p:txBody>
+          <a:bodyPr wrap="square" lIns="0" tIns="0" rIns="0" bIns="0" rtlCol="0" anchor="t"/>
+          <a:lstStyle/>
+          <a:p>
+            <a:pPr indent="0" marL="0">
+              <a:spcAft>
+                <a:spcPts val="200"/>
+              </a:spcAft>
+              <a:buNone/>
+            </a:pPr>
+            <a:r>
+              <a:rPr lang="en-US" sz="1150" b="1" dirty="0">
+                <a:solidFill>
+                  <a:srgbClr val="B85042"/>
+                </a:solidFill>
+                <a:latin typeface="Calibri" pitchFamily="34" charset="0"/>
+                <a:ea typeface="Calibri" pitchFamily="34" charset="-122"/>
+                <a:cs typeface="Calibri" pitchFamily="34" charset="-120"/>
+              </a:rPr>
+              <a:t/>
+            </a:r>
+            <a:pPr indent="0" marL="0">
+              <a:spcAft>
+                <a:spcPts val="200"/>
+              </a:spcAft>
+              <a:buNone/>
+            </a:pPr>
+            <a:endParaRPr lang="en-US" sz="1150" dirty="0"/>
+          </a:p>
+        </p:txBody>
+      </p:sp>
+      <p:sp>
+        <p:nvSpPr>
+          <p:cNvPr id="14" name="Text 12"/>
+          <p:cNvSpPr/>
+          <p:nvPr/>
+        </p:nvSpPr>
+        <p:spPr>
+          <a:xfrm>
+            <a:off x="4572000" y="1143000"/>
+            <a:ext cx="4389120" cy="292608"/>
+          </a:xfrm>
+          <a:prstGeom prst="rect">
+            <a:avLst/>
+          </a:prstGeom>
+          <a:noFill/>
+          <a:ln/>
+        </p:spPr>
+        <p:txBody>
+          <a:bodyPr wrap="square" lIns="0" tIns="0" rIns="0" bIns="0" rtlCol="0" anchor="t"/>
+          <a:lstStyle/>
+          <a:p>
+            <a:pPr indent="0" marL="0">
+              <a:buNone/>
+            </a:pPr>
+            <a:r>
+              <a:rPr lang="en-US" sz="1500" b="1" dirty="0">
+                <a:solidFill>
+                  <a:srgbClr val="B85042"/>
+                </a:solidFill>
+                <a:latin typeface="Calibri" pitchFamily="34" charset="0"/>
+                <a:ea typeface="Calibri" pitchFamily="34" charset="-122"/>
+                <a:cs typeface="Calibri" pitchFamily="34" charset="-120"/>
+              </a:rPr>
+              <a:t>Code  ·  deep_learning/model.py</a:t>
+            </a:r>
+            <a:endParaRPr lang="en-US" sz="1500" dirty="0"/>
+          </a:p>
+        </p:txBody>
+      </p:sp>
+      <p:sp>
+        <p:nvSpPr>
+          <p:cNvPr id="15" name="Shape 13"/>
+          <p:cNvSpPr/>
+          <p:nvPr/>
+        </p:nvSpPr>
+        <p:spPr>
+          <a:xfrm>
+            <a:off x="4572000" y="1508760"/>
+            <a:ext cx="4389120" cy="3383280"/>
+          </a:xfrm>
+          <a:prstGeom prst="rect">
+            <a:avLst/>
+          </a:prstGeom>
+          <a:solidFill>
+            <a:srgbClr val="1E293B"/>
+          </a:solidFill>
+          <a:ln w="12700">
+            <a:solidFill>
+              <a:srgbClr val="1E293B"/>
+            </a:solidFill>
+            <a:prstDash val="solid"/>
+          </a:ln>
+        </p:spPr>
+        <p:txBody>
+          <a:bodyPr/>
+          <a:p>
+            <a:r>
+              <a:t/>
+            </a:r>
+          </a:p>
+        </p:txBody>
+      </p:sp>
+      <p:sp>
+        <p:nvSpPr>
+          <p:cNvPr id="16" name="Text 14"/>
+          <p:cNvSpPr/>
+          <p:nvPr/>
+        </p:nvSpPr>
+        <p:spPr>
+          <a:xfrm>
+            <a:off x="4709160" y="1600200"/>
+            <a:ext cx="4114800" cy="3200400"/>
+          </a:xfrm>
+          <a:prstGeom prst="rect">
+            <a:avLst/>
+          </a:prstGeom>
+          <a:noFill/>
+          <a:ln/>
+        </p:spPr>
+        <p:txBody>
+          <a:bodyPr wrap="square" lIns="0" tIns="0" rIns="0" bIns="0" rtlCol="0" anchor="t"/>
+          <a:lstStyle/>
+          <a:p>
+            <a:pPr indent="0" marL="0">
+              <a:buNone/>
+            </a:pPr>
+            <a:r>
+              <a:rPr lang="en-US" sz="1050" dirty="0">
+                <a:solidFill>
+                  <a:srgbClr val="F0B27A"/>
+                </a:solidFill>
+                <a:latin typeface="Courier New" pitchFamily="34" charset="0"/>
+                <a:ea typeface="Courier New" pitchFamily="34" charset="-122"/>
+                <a:cs typeface="Courier New" pitchFamily="34" charset="-120"/>
+              </a:rPr>
+              <a:t>def build_efficientnet_b0(num_classes=4):</a:t>
+            </a:r>
+            <a:pPr indent="0" marL="0">
+              <a:buNone/>
+            </a:pPr>
+            <a:endParaRPr lang="en-US" sz="1050" dirty="0"/>
+          </a:p>
+          <a:p>
+            <a:r>
+              <a:rPr sz="1050" b="0">
+                <a:solidFill>
+                  <a:srgbClr val="F0B27A"/>
+                </a:solidFill>
+                <a:latin typeface="Courier New"/>
+              </a:rPr>
+              <a:t>    w = EfficientNet_B0_Weights.IMAGENET1K_V1</a:t>
+            </a:r>
+          </a:p>
+          <a:p>
+            <a:r>
+              <a:rPr sz="1050" b="0">
+                <a:solidFill>
+                  <a:srgbClr val="F0B27A"/>
+                </a:solidFill>
+                <a:latin typeface="Courier New"/>
+              </a:rPr>
+              <a:t>    m = efficientnet_b0(weights=w)</a:t>
+            </a:r>
+          </a:p>
+          <a:p>
+            <a:r>
+              <a:rPr sz="1050" b="0">
+                <a:solidFill>
+                  <a:srgbClr val="F0B27A"/>
+                </a:solidFill>
+                <a:latin typeface="Courier New"/>
+              </a:rPr>
+              <a:t>    in_f = m.classifier[1].in_features</a:t>
+            </a:r>
+          </a:p>
+          <a:p>
+            <a:r>
+              <a:rPr sz="1050" b="0">
+                <a:solidFill>
+                  <a:srgbClr val="F0B27A"/>
+                </a:solidFill>
+                <a:latin typeface="Courier New"/>
+              </a:rPr>
+              <a:t>    m.classifier = nn.Sequential(</a:t>
+            </a:r>
+          </a:p>
+          <a:p>
+            <a:r>
+              <a:rPr sz="1050" b="0">
+                <a:solidFill>
+                  <a:srgbClr val="F0B27A"/>
+                </a:solidFill>
+                <a:latin typeface="Courier New"/>
+              </a:rPr>
+              <a:t>        nn.Dropout(p=0.3),</a:t>
+            </a:r>
+          </a:p>
+          <a:p>
+            <a:r>
+              <a:rPr sz="1050" b="0">
+                <a:solidFill>
+                  <a:srgbClr val="F0B27A"/>
+                </a:solidFill>
+                <a:latin typeface="Courier New"/>
+              </a:rPr>
+              <a:t>        nn.Linear(in_f, num_classes))</a:t>
+            </a:r>
+          </a:p>
+          <a:p>
+            <a:r>
+              <a:rPr sz="1050" b="0">
+                <a:solidFill>
+                  <a:srgbClr val="F0B27A"/>
+                </a:solidFill>
+                <a:latin typeface="Courier New"/>
+              </a:rPr>
+              <a:t>    return m</a:t>
+            </a:r>
+          </a:p>
+          <a:p>
+            <a:r>
+              <a:rPr sz="1050" b="0">
+                <a:solidFill>
+                  <a:srgbClr val="F0B27A"/>
+                </a:solidFill>
+                <a:latin typeface="Courier New"/>
+              </a:rPr>
+              <a:t/>
+            </a:r>
+          </a:p>
+          <a:p>
+            <a:r>
+              <a:rPr sz="1050" b="0">
+                <a:solidFill>
+                  <a:srgbClr val="F0B27A"/>
+                </a:solidFill>
+                <a:latin typeface="Courier New"/>
+              </a:rPr>
+              <a:t>def build_convnextv2_base(num_classes=4,</a:t>
+            </a:r>
+          </a:p>
+          <a:p>
+            <a:r>
+              <a:rPr sz="1050" b="0">
+                <a:solidFill>
+                  <a:srgbClr val="F0B27A"/>
+                </a:solidFill>
+                <a:latin typeface="Courier New"/>
+              </a:rPr>
+              <a:t>                          image_size=384):</a:t>
+            </a:r>
+          </a:p>
+          <a:p>
+            <a:r>
+              <a:rPr sz="1050" b="0">
+                <a:solidFill>
+                  <a:srgbClr val="F0B27A"/>
+                </a:solidFill>
+                <a:latin typeface="Courier New"/>
+              </a:rPr>
+              <a:t>    name = 'convnextv2_base.' + (</a:t>
+            </a:r>
+          </a:p>
+          <a:p>
+            <a:r>
+              <a:rPr sz="1050" b="0">
+                <a:solidFill>
+                  <a:srgbClr val="F0B27A"/>
+                </a:solidFill>
+                <a:latin typeface="Courier New"/>
+              </a:rPr>
+              <a:t>        'fcmae_ft_in22k_in1k_384'</a:t>
+            </a:r>
+          </a:p>
+          <a:p>
+            <a:r>
+              <a:rPr sz="1050" b="0">
+                <a:solidFill>
+                  <a:srgbClr val="F0B27A"/>
+                </a:solidFill>
+                <a:latin typeface="Courier New"/>
+              </a:rPr>
+              <a:t>        if image_size &gt;= 384</a:t>
+            </a:r>
+          </a:p>
+          <a:p>
+            <a:r>
+              <a:rPr sz="1050" b="0">
+                <a:solidFill>
+                  <a:srgbClr val="F0B27A"/>
+                </a:solidFill>
+                <a:latin typeface="Courier New"/>
+              </a:rPr>
+              <a:t>        else 'fcmae_ft_in22k_in1k')</a:t>
+            </a:r>
+          </a:p>
+          <a:p>
+            <a:r>
+              <a:rPr sz="1050" b="0">
+                <a:solidFill>
+                  <a:srgbClr val="F0B27A"/>
+                </a:solidFill>
+                <a:latin typeface="Courier New"/>
+              </a:rPr>
+              <a:t>    return timm.create_model(name,</a:t>
+            </a:r>
+          </a:p>
+          <a:p>
+            <a:r>
+              <a:rPr sz="1050" b="0">
+                <a:solidFill>
+                  <a:srgbClr val="F0B27A"/>
+                </a:solidFill>
+                <a:latin typeface="Courier New"/>
+              </a:rPr>
+              <a:t>        pretrained=True,</a:t>
+            </a:r>
+          </a:p>
+          <a:p>
+            <a:r>
+              <a:rPr sz="1050" b="0">
+                <a:solidFill>
+                  <a:srgbClr val="F0B27A"/>
+                </a:solidFill>
+                <a:latin typeface="Courier New"/>
+              </a:rPr>
+              <a:t>        num_classes=num_classes,</a:t>
+            </a:r>
+          </a:p>
+          <a:p>
+            <a:r>
+              <a:rPr sz="1050" b="0">
+                <a:solidFill>
+                  <a:srgbClr val="F0B27A"/>
+                </a:solidFill>
+                <a:latin typeface="Courier New"/>
+              </a:rPr>
+              <a:t>        drop_path_rate=0.3, drop_rate=0.3)</a:t>
+            </a:r>
+          </a:p>
+        </p:txBody>
+      </p:sp>
+    </p:spTree>
+  </p:cSld>
+  <p:clrMapOvr>
+    <a:masterClrMapping/>
+  </p:clrMapOvr>
+</p:sld>
+</file>
+
+<file path=ppt/slides/slide13.xml><?xml version="1.0" encoding="utf-8"?>
+<p:sld xmlns:a="http://schemas.openxmlformats.org/drawingml/2006/main" xmlns:p="http://schemas.openxmlformats.org/presentationml/2006/main" xmlns:r="http://schemas.openxmlformats.org/officeDocument/2006/relationships">
+  <p:cSld>
+    <p:spTree>
+      <p:nvGrpSpPr>
+        <p:cNvPr id="1" name=""/>
+        <p:cNvGrpSpPr/>
+        <p:nvPr/>
+      </p:nvGrpSpPr>
+      <p:grpSpPr/>
+      <p:sp>
+        <p:nvSpPr>
+          <p:cNvPr id="2" name="Text 0"/>
+          <p:cNvSpPr/>
+          <p:nvPr/>
+        </p:nvSpPr>
+        <p:spPr>
+          <a:xfrm>
+            <a:off x="457200" y="292608"/>
+            <a:ext cx="7772400" cy="502920"/>
+          </a:xfrm>
+          <a:prstGeom prst="rect">
+            <a:avLst/>
+          </a:prstGeom>
+          <a:noFill/>
+          <a:ln/>
+        </p:spPr>
+        <p:txBody>
+          <a:bodyPr wrap="square" lIns="0" tIns="0" rIns="0" bIns="0" rtlCol="0" anchor="t"/>
+          <a:lstStyle/>
+          <a:p>
+            <a:pPr indent="0" marL="0">
+              <a:buNone/>
+            </a:pPr>
+            <a:r>
+              <a:rPr lang="en-US" sz="2800" b="1" dirty="0">
+                <a:solidFill>
+                  <a:srgbClr val="2D3142"/>
+                </a:solidFill>
+                <a:latin typeface="Calibri" pitchFamily="34" charset="0"/>
+                <a:ea typeface="Calibri" pitchFamily="34" charset="-122"/>
+                <a:cs typeface="Calibri" pitchFamily="34" charset="-120"/>
+              </a:rPr>
+              <a:t>DL Inference  ·  predict() + TTA</a:t>
+            </a:r>
+            <a:endParaRPr lang="en-US" sz="2800" dirty="0"/>
+          </a:p>
+        </p:txBody>
+      </p:sp>
+      <p:sp>
+        <p:nvSpPr>
+          <p:cNvPr id="3" name="Text 1"/>
+          <p:cNvSpPr/>
+          <p:nvPr/>
+        </p:nvSpPr>
+        <p:spPr>
+          <a:xfrm>
+            <a:off x="5943600" y="292608"/>
+            <a:ext cx="2834640" cy="292608"/>
+          </a:xfrm>
+          <a:prstGeom prst="rect">
+            <a:avLst/>
+          </a:prstGeom>
+          <a:noFill/>
+          <a:ln/>
+        </p:spPr>
+        <p:txBody>
+          <a:bodyPr wrap="square" lIns="0" tIns="0" rIns="0" bIns="0" rtlCol="0" anchor="t"/>
+          <a:lstStyle/>
+          <a:p>
+            <a:pPr algn="r" indent="0" marL="0">
+              <a:buNone/>
+            </a:pPr>
+            <a:r>
+              <a:rPr lang="en-US" sz="900" b="1" spc="400" kern="0" dirty="0">
+                <a:solidFill>
+                  <a:srgbClr val="75948A"/>
+                </a:solidFill>
+                <a:latin typeface="Calibri" pitchFamily="34" charset="0"/>
+                <a:ea typeface="Calibri" pitchFamily="34" charset="-122"/>
+                <a:cs typeface="Calibri" pitchFamily="34" charset="-120"/>
+              </a:rPr>
+              <a:t>METHODS · DEEP LEARNING · JAMES</a:t>
+            </a:r>
+            <a:endParaRPr lang="en-US" sz="900" dirty="0"/>
+          </a:p>
+        </p:txBody>
+      </p:sp>
+      <p:sp>
+        <p:nvSpPr>
+          <p:cNvPr id="4" name="Text 2"/>
+          <p:cNvSpPr/>
+          <p:nvPr/>
+        </p:nvSpPr>
+        <p:spPr>
+          <a:xfrm>
+            <a:off x="457200" y="1143000"/>
+            <a:ext cx="3931920" cy="292608"/>
+          </a:xfrm>
+          <a:prstGeom prst="rect">
+            <a:avLst/>
+          </a:prstGeom>
+          <a:noFill/>
+          <a:ln/>
+        </p:spPr>
+        <p:txBody>
+          <a:bodyPr wrap="square" lIns="0" tIns="0" rIns="0" bIns="0" rtlCol="0" anchor="t"/>
+          <a:lstStyle/>
+          <a:p>
+            <a:pPr indent="0" marL="0">
+              <a:buNone/>
+            </a:pPr>
+            <a:r>
+              <a:rPr lang="en-US" sz="1500" b="1" dirty="0">
+                <a:solidFill>
+                  <a:srgbClr val="B85042"/>
+                </a:solidFill>
+                <a:latin typeface="Calibri" pitchFamily="34" charset="0"/>
+                <a:ea typeface="Calibri" pitchFamily="34" charset="-122"/>
+                <a:cs typeface="Calibri" pitchFamily="34" charset="-120"/>
+              </a:rPr>
+              <a:t>From checkpoint → softmax</a:t>
+            </a:r>
+            <a:endParaRPr lang="en-US" sz="1500" dirty="0"/>
+          </a:p>
+        </p:txBody>
+      </p:sp>
+      <p:sp>
+        <p:nvSpPr>
+          <p:cNvPr id="5" name="Shape 3"/>
+          <p:cNvSpPr/>
+          <p:nvPr/>
+        </p:nvSpPr>
+        <p:spPr>
+          <a:xfrm>
+            <a:off x="457200" y="1508760"/>
+            <a:ext cx="3931920" cy="777240"/>
+          </a:xfrm>
+          <a:prstGeom prst="rect">
+            <a:avLst/>
+          </a:prstGeom>
+          <a:solidFill>
+            <a:srgbClr val="EDE6D6"/>
+          </a:solidFill>
+          <a:ln w="12700">
+            <a:solidFill>
+              <a:srgbClr val="EDE6D6"/>
+            </a:solidFill>
+            <a:prstDash val="solid"/>
+          </a:ln>
+        </p:spPr>
+        <p:txBody>
+          <a:bodyPr/>
+          <a:p>
+            <a:r>
+              <a:t/>
+            </a:r>
+          </a:p>
+        </p:txBody>
+      </p:sp>
+      <p:sp>
+        <p:nvSpPr>
+          <p:cNvPr id="6" name="Shape 4"/>
+          <p:cNvSpPr/>
+          <p:nvPr/>
+        </p:nvSpPr>
+        <p:spPr>
+          <a:xfrm>
+            <a:off x="457200" y="1508760"/>
+            <a:ext cx="91440" cy="777240"/>
+          </a:xfrm>
+          <a:prstGeom prst="rect">
+            <a:avLst/>
+          </a:prstGeom>
+          <a:solidFill>
+            <a:srgbClr val="75948A"/>
+          </a:solidFill>
+          <a:ln w="12700">
+            <a:solidFill>
+              <a:srgbClr val="75948A"/>
+            </a:solidFill>
+            <a:prstDash val="solid"/>
+          </a:ln>
+        </p:spPr>
+        <p:txBody>
+          <a:bodyPr/>
+          <a:p>
+            <a:r>
+              <a:t/>
+            </a:r>
+          </a:p>
+        </p:txBody>
+      </p:sp>
+      <p:sp>
+        <p:nvSpPr>
+          <p:cNvPr id="7" name="Text 5"/>
+          <p:cNvSpPr/>
+          <p:nvPr/>
+        </p:nvSpPr>
+        <p:spPr>
+          <a:xfrm>
+            <a:off x="640080" y="1554480"/>
+            <a:ext cx="3657600" cy="228600"/>
+          </a:xfrm>
+          <a:prstGeom prst="rect">
+            <a:avLst/>
+          </a:prstGeom>
+          <a:noFill/>
+          <a:ln/>
+        </p:spPr>
+        <p:txBody>
+          <a:bodyPr wrap="square" lIns="0" tIns="0" rIns="0" bIns="0" rtlCol="0" anchor="t"/>
+          <a:lstStyle/>
+          <a:p>
+            <a:pPr indent="0" marL="0">
+              <a:buNone/>
+            </a:pPr>
+            <a:r>
+              <a:rPr lang="en-US" sz="1000" b="1" spc="300" kern="0" dirty="0">
+                <a:solidFill>
+                  <a:srgbClr val="75948A"/>
+                </a:solidFill>
+                <a:latin typeface="Calibri" pitchFamily="34" charset="0"/>
+                <a:ea typeface="Calibri" pitchFamily="34" charset="-122"/>
+                <a:cs typeface="Calibri" pitchFamily="34" charset="-120"/>
+              </a:rPr>
+              <a:t/>
+            </a:r>
+            <a:endParaRPr lang="en-US" sz="1000" dirty="0"/>
+          </a:p>
+        </p:txBody>
+      </p:sp>
+      <p:sp>
+        <p:nvSpPr>
+          <p:cNvPr id="8" name="Text 6"/>
+          <p:cNvSpPr/>
+          <p:nvPr/>
+        </p:nvSpPr>
+        <p:spPr>
+          <a:xfrm>
+            <a:off x="640080" y="1801368"/>
+            <a:ext cx="3657600" cy="411480"/>
+          </a:xfrm>
+          <a:prstGeom prst="rect">
+            <a:avLst/>
+          </a:prstGeom>
+          <a:noFill/>
+          <a:ln/>
+        </p:spPr>
+        <p:txBody>
+          <a:bodyPr wrap="square" lIns="0" tIns="0" rIns="0" bIns="0" rtlCol="0" anchor="t"/>
+          <a:lstStyle/>
+          <a:p>
+            <a:pPr indent="0" marL="0">
+              <a:buNone/>
+            </a:pPr>
+            <a:r>
+              <a:rPr lang="en-US" sz="1250" dirty="0">
+                <a:solidFill>
+                  <a:srgbClr val="2D3142"/>
+                </a:solidFill>
+                <a:latin typeface="Calibri" pitchFamily="34" charset="0"/>
+                <a:ea typeface="Calibri" pitchFamily="34" charset="-122"/>
+                <a:cs typeface="Calibri" pitchFamily="34" charset="-120"/>
+              </a:rPr>
+              <a:t/>
+            </a:r>
+            <a:endParaRPr lang="en-US" sz="1250" dirty="0"/>
+          </a:p>
+        </p:txBody>
+      </p:sp>
+      <p:sp>
+        <p:nvSpPr>
+          <p:cNvPr id="9" name="Shape 7"/>
+          <p:cNvSpPr/>
+          <p:nvPr/>
+        </p:nvSpPr>
+        <p:spPr>
+          <a:xfrm>
+            <a:off x="457200" y="2377440"/>
+            <a:ext cx="3931920" cy="1463040"/>
+          </a:xfrm>
+          <a:prstGeom prst="rect">
+            <a:avLst/>
+          </a:prstGeom>
+          <a:solidFill>
+            <a:srgbClr val="EDE6D6"/>
+          </a:solidFill>
+          <a:ln w="12700">
+            <a:solidFill>
+              <a:srgbClr val="EDE6D6"/>
+            </a:solidFill>
+            <a:prstDash val="solid"/>
+          </a:ln>
+        </p:spPr>
+        <p:txBody>
+          <a:bodyPr/>
+          <a:p>
+            <a:r>
+              <a:rPr>
+                <a:solidFill/>
+              </a:rPr>
+              <a:t>Load best_model.pt into the same builder</a:t>
+            </a:r>
+          </a:p>
+          <a:p>
+            <a:r>
+              <a:rPr b="0"/>
+              <a:t>Forward each batch under torch.no_grad()</a:t>
+            </a:r>
+          </a:p>
+          <a:p>
+            <a:r>
+              <a:rPr b="0"/>
+              <a:t>softmax → argmax for predictions</a:t>
+            </a:r>
+          </a:p>
+          <a:p>
+            <a:r>
+              <a:rPr b="0"/>
+              <a:t>Save y_true, y_pred, y_prob as .npz</a:t>
+            </a:r>
+          </a:p>
+          <a:p>
+            <a:r>
+              <a:rPr b="0"/>
+              <a:t/>
+            </a:r>
+          </a:p>
+          <a:p>
+            <a:r>
+              <a:rPr b="0"/>
+              <a:t>TTA at inference (hflip):</a:t>
+            </a:r>
+          </a:p>
+          <a:p>
+            <a:r>
+              <a:rPr b="0"/>
+              <a:t>  Predict on original + horizontally flipped</a:t>
+            </a:r>
+          </a:p>
+          <a:p>
+            <a:r>
+              <a:rPr b="0"/>
+              <a:t>  Average the two softmax vectors</a:t>
+            </a:r>
+          </a:p>
+          <a:p>
+            <a:r>
+              <a:rPr b="0"/>
+              <a:t>  argmax of the average → final prediction</a:t>
+            </a:r>
+          </a:p>
+          <a:p>
+            <a:r>
+              <a:rPr b="0"/>
+              <a:t/>
+            </a:r>
+          </a:p>
+          <a:p>
+            <a:r>
+              <a:rPr b="0"/>
+              <a:t>Cost: 2× inference time, no retraining</a:t>
+            </a:r>
+          </a:p>
+        </p:txBody>
+      </p:sp>
+      <p:sp>
+        <p:nvSpPr>
+          <p:cNvPr id="10" name="Shape 8"/>
+          <p:cNvSpPr/>
+          <p:nvPr/>
+        </p:nvSpPr>
+        <p:spPr>
+          <a:xfrm>
+            <a:off x="457200" y="2377440"/>
+            <a:ext cx="91440" cy="1463040"/>
+          </a:xfrm>
+          <a:prstGeom prst="rect">
+            <a:avLst/>
+          </a:prstGeom>
+          <a:solidFill>
+            <a:srgbClr val="B85042"/>
+          </a:solidFill>
+          <a:ln w="12700">
+            <a:solidFill>
+              <a:srgbClr val="B85042"/>
+            </a:solidFill>
+            <a:prstDash val="solid"/>
+          </a:ln>
+        </p:spPr>
+        <p:txBody>
+          <a:bodyPr/>
+          <a:p>
+            <a:r>
+              <a:t/>
+            </a:r>
+          </a:p>
+        </p:txBody>
+      </p:sp>
+      <p:sp>
+        <p:nvSpPr>
+          <p:cNvPr id="11" name="Text 9"/>
+          <p:cNvSpPr/>
+          <p:nvPr/>
+        </p:nvSpPr>
+        <p:spPr>
+          <a:xfrm>
+            <a:off x="640080" y="2423160"/>
+            <a:ext cx="3657600" cy="228600"/>
+          </a:xfrm>
+          <a:prstGeom prst="rect">
+            <a:avLst/>
+          </a:prstGeom>
+          <a:noFill/>
+          <a:ln/>
+        </p:spPr>
+        <p:txBody>
+          <a:bodyPr wrap="square" lIns="0" tIns="0" rIns="0" bIns="0" rtlCol="0" anchor="t"/>
+          <a:lstStyle/>
+          <a:p>
+            <a:pPr indent="0" marL="0">
+              <a:buNone/>
+            </a:pPr>
+            <a:r>
+              <a:rPr lang="en-US" sz="1000" b="1" spc="300" kern="0" dirty="0">
+                <a:solidFill>
+                  <a:srgbClr val="B85042"/>
+                </a:solidFill>
+                <a:latin typeface="Calibri" pitchFamily="34" charset="0"/>
+                <a:ea typeface="Calibri" pitchFamily="34" charset="-122"/>
+                <a:cs typeface="Calibri" pitchFamily="34" charset="-120"/>
+              </a:rPr>
+              <a:t/>
+            </a:r>
+            <a:endParaRPr lang="en-US" sz="1000" dirty="0"/>
+          </a:p>
+        </p:txBody>
+      </p:sp>
+      <p:sp>
+        <p:nvSpPr>
+          <p:cNvPr id="12" name="Text 10"/>
+          <p:cNvSpPr/>
+          <p:nvPr/>
+        </p:nvSpPr>
+        <p:spPr>
+          <a:xfrm>
+            <a:off x="640080" y="2651760"/>
+            <a:ext cx="3657600" cy="1280160"/>
+          </a:xfrm>
+          <a:prstGeom prst="rect">
+            <a:avLst/>
+          </a:prstGeom>
+          <a:noFill/>
+          <a:ln/>
+        </p:spPr>
+        <p:txBody>
+          <a:bodyPr wrap="square" lIns="0" tIns="0" rIns="0" bIns="0" rtlCol="0" anchor="t"/>
+          <a:lstStyle/>
+          <a:p>
+            <a:pPr indent="0" marL="0">
+              <a:spcAft>
+                <a:spcPts val="200"/>
+              </a:spcAft>
+              <a:buNone/>
+            </a:pPr>
+            <a:r>
+              <a:rPr lang="en-US" sz="1150" dirty="0">
+                <a:solidFill>
+                  <a:srgbClr val="2D3142"/>
+                </a:solidFill>
+                <a:latin typeface="Calibri" pitchFamily="34" charset="0"/>
+                <a:ea typeface="Calibri" pitchFamily="34" charset="-122"/>
+                <a:cs typeface="Calibri" pitchFamily="34" charset="-120"/>
+              </a:rPr>
+              <a:t/>
+            </a:r>
+            <a:endParaRPr lang="en-US" sz="1150" dirty="0"/>
+          </a:p>
+        </p:txBody>
+      </p:sp>
+      <p:sp>
+        <p:nvSpPr>
+          <p:cNvPr id="13" name="Text 11"/>
+          <p:cNvSpPr/>
+          <p:nvPr/>
+        </p:nvSpPr>
+        <p:spPr>
+          <a:xfrm>
+            <a:off x="457200" y="3977640"/>
+            <a:ext cx="3931920" cy="548640"/>
+          </a:xfrm>
+          <a:prstGeom prst="rect">
+            <a:avLst/>
+          </a:prstGeom>
+          <a:noFill/>
+          <a:ln/>
+        </p:spPr>
+        <p:txBody>
+          <a:bodyPr wrap="square" lIns="0" tIns="0" rIns="0" bIns="0" rtlCol="0" anchor="t"/>
+          <a:lstStyle/>
+          <a:p>
+            <a:pPr indent="0" marL="0">
+              <a:spcAft>
+                <a:spcPts val="200"/>
+              </a:spcAft>
+              <a:buNone/>
+            </a:pPr>
+            <a:r>
+              <a:rPr lang="en-US" sz="1150" b="1" dirty="0">
+                <a:solidFill>
+                  <a:srgbClr val="B85042"/>
+                </a:solidFill>
+                <a:latin typeface="Calibri" pitchFamily="34" charset="0"/>
+                <a:ea typeface="Calibri" pitchFamily="34" charset="-122"/>
+                <a:cs typeface="Calibri" pitchFamily="34" charset="-120"/>
+              </a:rPr>
+              <a:t/>
+            </a:r>
+            <a:pPr indent="0" marL="0">
+              <a:spcAft>
+                <a:spcPts val="200"/>
+              </a:spcAft>
+              <a:buNone/>
+            </a:pPr>
+            <a:endParaRPr lang="en-US" sz="1150" dirty="0"/>
+          </a:p>
+        </p:txBody>
+      </p:sp>
+      <p:sp>
+        <p:nvSpPr>
+          <p:cNvPr id="14" name="Text 12"/>
+          <p:cNvSpPr/>
+          <p:nvPr/>
+        </p:nvSpPr>
+        <p:spPr>
+          <a:xfrm>
+            <a:off x="4572000" y="1143000"/>
+            <a:ext cx="4389120" cy="292608"/>
+          </a:xfrm>
+          <a:prstGeom prst="rect">
+            <a:avLst/>
+          </a:prstGeom>
+          <a:noFill/>
+          <a:ln/>
+        </p:spPr>
+        <p:txBody>
+          <a:bodyPr wrap="square" lIns="0" tIns="0" rIns="0" bIns="0" rtlCol="0" anchor="t"/>
+          <a:lstStyle/>
+          <a:p>
+            <a:pPr indent="0" marL="0">
+              <a:buNone/>
+            </a:pPr>
+            <a:r>
+              <a:rPr lang="en-US" sz="1500" b="1" dirty="0">
+                <a:solidFill>
+                  <a:srgbClr val="B85042"/>
+                </a:solidFill>
+                <a:latin typeface="Calibri" pitchFamily="34" charset="0"/>
+                <a:ea typeface="Calibri" pitchFamily="34" charset="-122"/>
+                <a:cs typeface="Calibri" pitchFamily="34" charset="-120"/>
+              </a:rPr>
+              <a:t>Code  ·  predict + TTA</a:t>
+            </a:r>
+            <a:endParaRPr lang="en-US" sz="1500" dirty="0"/>
+          </a:p>
+        </p:txBody>
+      </p:sp>
+      <p:sp>
+        <p:nvSpPr>
+          <p:cNvPr id="15" name="Shape 13"/>
+          <p:cNvSpPr/>
+          <p:nvPr/>
+        </p:nvSpPr>
+        <p:spPr>
+          <a:xfrm>
+            <a:off x="4572000" y="1508760"/>
+            <a:ext cx="4389120" cy="3383280"/>
+          </a:xfrm>
+          <a:prstGeom prst="rect">
+            <a:avLst/>
+          </a:prstGeom>
+          <a:solidFill>
+            <a:srgbClr val="1E293B"/>
+          </a:solidFill>
+          <a:ln w="12700">
+            <a:solidFill>
+              <a:srgbClr val="1E293B"/>
+            </a:solidFill>
+            <a:prstDash val="solid"/>
+          </a:ln>
+        </p:spPr>
+        <p:txBody>
+          <a:bodyPr/>
+          <a:p>
+            <a:r>
+              <a:t/>
+            </a:r>
+          </a:p>
+        </p:txBody>
+      </p:sp>
+      <p:sp>
+        <p:nvSpPr>
+          <p:cNvPr id="16" name="Text 14"/>
+          <p:cNvSpPr/>
+          <p:nvPr/>
+        </p:nvSpPr>
+        <p:spPr>
+          <a:xfrm>
+            <a:off x="4709160" y="1600200"/>
+            <a:ext cx="4114800" cy="3200400"/>
+          </a:xfrm>
+          <a:prstGeom prst="rect">
+            <a:avLst/>
+          </a:prstGeom>
+          <a:noFill/>
+          <a:ln/>
+        </p:spPr>
+        <p:txBody>
+          <a:bodyPr wrap="square" lIns="0" tIns="0" rIns="0" bIns="0" rtlCol="0" anchor="t"/>
+          <a:lstStyle/>
+          <a:p>
+            <a:pPr indent="0" marL="0">
+              <a:buNone/>
+            </a:pPr>
+            <a:r>
+              <a:rPr lang="en-US" sz="1050" dirty="0">
+                <a:solidFill>
+                  <a:srgbClr val="F0B27A"/>
+                </a:solidFill>
+                <a:latin typeface="Courier New" pitchFamily="34" charset="0"/>
+                <a:ea typeface="Courier New" pitchFamily="34" charset="-122"/>
+                <a:cs typeface="Courier New" pitchFamily="34" charset="-120"/>
+              </a:rPr>
+              <a:t>@torch.no_grad()</a:t>
+            </a:r>
+            <a:pPr indent="0" marL="0">
+              <a:buNone/>
+            </a:pPr>
+            <a:endParaRPr lang="en-US" sz="1050" dirty="0"/>
+          </a:p>
+          <a:p>
+            <a:r>
+              <a:rPr sz="1050" b="0">
+                <a:solidFill>
+                  <a:srgbClr val="F0B27A"/>
+                </a:solidFill>
+                <a:latin typeface="Courier New"/>
+              </a:rPr>
+              <a:t>def predict(ckpt, model_name, image_size):</a:t>
+            </a:r>
+          </a:p>
+          <a:p>
+            <a:r>
+              <a:rPr sz="1050" b="0">
+                <a:solidFill>
+                  <a:srgbClr val="F0B27A"/>
+                </a:solidFill>
+                <a:latin typeface="Courier New"/>
+              </a:rPr>
+              <a:t>    model = build_model(</a:t>
+            </a:r>
+          </a:p>
+          <a:p>
+            <a:r>
+              <a:rPr sz="1050" b="0">
+                <a:solidFill>
+                  <a:srgbClr val="F0B27A"/>
+                </a:solidFill>
+                <a:latin typeface="Courier New"/>
+              </a:rPr>
+              <a:t>        name=model_name,</a:t>
+            </a:r>
+          </a:p>
+          <a:p>
+            <a:r>
+              <a:rPr sz="1050" b="0">
+                <a:solidFill>
+                  <a:srgbClr val="F0B27A"/>
+                </a:solidFill>
+                <a:latin typeface="Courier New"/>
+              </a:rPr>
+              <a:t>        image_size=image_size).to(device)</a:t>
+            </a:r>
+          </a:p>
+          <a:p>
+            <a:r>
+              <a:rPr sz="1050" b="0">
+                <a:solidFill>
+                  <a:srgbClr val="F0B27A"/>
+                </a:solidFill>
+                <a:latin typeface="Courier New"/>
+              </a:rPr>
+              <a:t>    model.load_state_dict(</a:t>
+            </a:r>
+          </a:p>
+          <a:p>
+            <a:r>
+              <a:rPr sz="1050" b="0">
+                <a:solidFill>
+                  <a:srgbClr val="F0B27A"/>
+                </a:solidFill>
+                <a:latin typeface="Courier New"/>
+              </a:rPr>
+              <a:t>        torch.load(ckpt, map_location=device))</a:t>
+            </a:r>
+          </a:p>
+          <a:p>
+            <a:r>
+              <a:rPr sz="1050" b="0">
+                <a:solidFill>
+                  <a:srgbClr val="F0B27A"/>
+                </a:solidFill>
+                <a:latin typeface="Courier New"/>
+              </a:rPr>
+              <a:t>    model.eval()</a:t>
+            </a:r>
+          </a:p>
+          <a:p>
+            <a:r>
+              <a:rPr sz="1050" b="0">
+                <a:solidFill>
+                  <a:srgbClr val="F0B27A"/>
+                </a:solidFill>
+                <a:latin typeface="Courier New"/>
+              </a:rPr>
+              <a:t>    # forward → softmax → argmax (batched)</a:t>
+            </a:r>
+          </a:p>
+          <a:p>
+            <a:r>
+              <a:rPr sz="1050" b="0">
+                <a:solidFill>
+                  <a:srgbClr val="F0B27A"/>
+                </a:solidFill>
+                <a:latin typeface="Courier New"/>
+              </a:rPr>
+              <a:t>    return {'y_true': y, 'y_pred': p,</a:t>
+            </a:r>
+          </a:p>
+          <a:p>
+            <a:r>
+              <a:rPr sz="1050" b="0">
+                <a:solidFill>
+                  <a:srgbClr val="F0B27A"/>
+                </a:solidFill>
+                <a:latin typeface="Courier New"/>
+              </a:rPr>
+              <a:t>            'y_prob': probs}</a:t>
+            </a:r>
+          </a:p>
+          <a:p>
+            <a:r>
+              <a:rPr sz="1050" b="0">
+                <a:solidFill>
+                  <a:srgbClr val="F0B27A"/>
+                </a:solidFill>
+                <a:latin typeface="Courier New"/>
+              </a:rPr>
+              <a:t/>
+            </a:r>
+          </a:p>
+          <a:p>
+            <a:r>
+              <a:rPr sz="1050" b="0">
+                <a:solidFill>
+                  <a:srgbClr val="F0B27A"/>
+                </a:solidFill>
+                <a:latin typeface="Courier New"/>
+              </a:rPr>
+              <a:t># TTA hflip — 2-view averaged softmax</a:t>
+            </a:r>
+          </a:p>
+          <a:p>
+            <a:r>
+              <a:rPr sz="1050" b="0">
+                <a:solidFill>
+                  <a:srgbClr val="F0B27A"/>
+                </a:solidFill>
+                <a:latin typeface="Courier New"/>
+              </a:rPr>
+              <a:t>def tta_views_hflip(img_256):</a:t>
+            </a:r>
+          </a:p>
+          <a:p>
+            <a:r>
+              <a:rPr sz="1050" b="0">
+                <a:solidFill>
+                  <a:srgbClr val="F0B27A"/>
+                </a:solidFill>
+                <a:latin typeface="Courier New"/>
+              </a:rPr>
+              <a:t>    pil = Image.fromarray(img_256, mode='L')</a:t>
+            </a:r>
+          </a:p>
+          <a:p>
+            <a:r>
+              <a:rPr sz="1050" b="0">
+                <a:solidFill>
+                  <a:srgbClr val="F0B27A"/>
+                </a:solidFill>
+                <a:latin typeface="Courier New"/>
+              </a:rPr>
+              <a:t>    flip = pil.transpose(</a:t>
+            </a:r>
+          </a:p>
+          <a:p>
+            <a:r>
+              <a:rPr sz="1050" b="0">
+                <a:solidFill>
+                  <a:srgbClr val="F0B27A"/>
+                </a:solidFill>
+                <a:latin typeface="Courier New"/>
+              </a:rPr>
+              <a:t>        Image.FLIP_LEFT_RIGHT)</a:t>
+            </a:r>
+          </a:p>
+          <a:p>
+            <a:r>
+              <a:rPr sz="1050" b="0">
+                <a:solidFill>
+                  <a:srgbClr val="F0B27A"/>
+                </a:solidFill>
+                <a:latin typeface="Courier New"/>
+              </a:rPr>
+              <a:t>    return [np.asarray(pil),</a:t>
+            </a:r>
+          </a:p>
+          <a:p>
+            <a:r>
+              <a:rPr sz="1050" b="0">
+                <a:solidFill>
+                  <a:srgbClr val="F0B27A"/>
+                </a:solidFill>
+                <a:latin typeface="Courier New"/>
+              </a:rPr>
+              <a:t>            np.asarray(flip)]</a:t>
+            </a:r>
           </a:p>
         </p:txBody>
       </p:sp>

</xml_diff>